<commit_message>
Update Topic 4 - Classification.pptx
</commit_message>
<xml_diff>
--- a/Course content/Slides/Topic 4 - Classification.pptx
+++ b/Course content/Slides/Topic 4 - Classification.pptx
@@ -5,7 +5,7 @@
     <p:sldMasterId id="2147483648" r:id="rId1"/>
   </p:sldMasterIdLst>
   <p:notesMasterIdLst>
-    <p:notesMasterId r:id="rId26"/>
+    <p:notesMasterId r:id="rId24"/>
   </p:notesMasterIdLst>
   <p:sldIdLst>
     <p:sldId id="278" r:id="rId2"/>
@@ -24,14 +24,12 @@
     <p:sldId id="290" r:id="rId15"/>
     <p:sldId id="291" r:id="rId16"/>
     <p:sldId id="292" r:id="rId17"/>
-    <p:sldId id="293" r:id="rId18"/>
-    <p:sldId id="294" r:id="rId19"/>
-    <p:sldId id="295" r:id="rId20"/>
-    <p:sldId id="296" r:id="rId21"/>
-    <p:sldId id="297" r:id="rId22"/>
-    <p:sldId id="298" r:id="rId23"/>
-    <p:sldId id="299" r:id="rId24"/>
-    <p:sldId id="300" r:id="rId25"/>
+    <p:sldId id="294" r:id="rId18"/>
+    <p:sldId id="295" r:id="rId19"/>
+    <p:sldId id="296" r:id="rId20"/>
+    <p:sldId id="297" r:id="rId21"/>
+    <p:sldId id="298" r:id="rId22"/>
+    <p:sldId id="299" r:id="rId23"/>
   </p:sldIdLst>
   <p:sldSz cx="12192000" cy="6858000"/>
   <p:notesSz cx="6858000" cy="9144000"/>
@@ -231,7 +229,7 @@
           <a:p>
             <a:fld id="{B9B1DC7F-8587-4047-9A5D-1FCB6614CAE0}" type="datetimeFigureOut">
               <a:rPr lang="en-US" smtClean="0"/>
-              <a:t>10/24/2022</a:t>
+              <a:t>10/25/2022</a:t>
             </a:fld>
             <a:endParaRPr lang="en-US"/>
           </a:p>
@@ -645,7 +643,7 @@
           <a:p>
             <a:fld id="{A7DB5662-7327-465C-9A70-AD96B7A8D67A}" type="datetimeFigureOut">
               <a:rPr lang="en-US" smtClean="0"/>
-              <a:t>10/24/2022</a:t>
+              <a:t>10/25/2022</a:t>
             </a:fld>
             <a:endParaRPr lang="en-US"/>
           </a:p>
@@ -843,7 +841,7 @@
           <a:p>
             <a:fld id="{A7DB5662-7327-465C-9A70-AD96B7A8D67A}" type="datetimeFigureOut">
               <a:rPr lang="en-US" smtClean="0"/>
-              <a:t>10/24/2022</a:t>
+              <a:t>10/25/2022</a:t>
             </a:fld>
             <a:endParaRPr lang="en-US"/>
           </a:p>
@@ -1051,7 +1049,7 @@
           <a:p>
             <a:fld id="{A7DB5662-7327-465C-9A70-AD96B7A8D67A}" type="datetimeFigureOut">
               <a:rPr lang="en-US" smtClean="0"/>
-              <a:t>10/24/2022</a:t>
+              <a:t>10/25/2022</a:t>
             </a:fld>
             <a:endParaRPr lang="en-US"/>
           </a:p>
@@ -1249,7 +1247,7 @@
           <a:p>
             <a:fld id="{A7DB5662-7327-465C-9A70-AD96B7A8D67A}" type="datetimeFigureOut">
               <a:rPr lang="en-US" smtClean="0"/>
-              <a:t>10/24/2022</a:t>
+              <a:t>10/25/2022</a:t>
             </a:fld>
             <a:endParaRPr lang="en-US"/>
           </a:p>
@@ -1524,7 +1522,7 @@
           <a:p>
             <a:fld id="{A7DB5662-7327-465C-9A70-AD96B7A8D67A}" type="datetimeFigureOut">
               <a:rPr lang="en-US" smtClean="0"/>
-              <a:t>10/24/2022</a:t>
+              <a:t>10/25/2022</a:t>
             </a:fld>
             <a:endParaRPr lang="en-US"/>
           </a:p>
@@ -1789,7 +1787,7 @@
           <a:p>
             <a:fld id="{A7DB5662-7327-465C-9A70-AD96B7A8D67A}" type="datetimeFigureOut">
               <a:rPr lang="en-US" smtClean="0"/>
-              <a:t>10/24/2022</a:t>
+              <a:t>10/25/2022</a:t>
             </a:fld>
             <a:endParaRPr lang="en-US"/>
           </a:p>
@@ -2201,7 +2199,7 @@
           <a:p>
             <a:fld id="{A7DB5662-7327-465C-9A70-AD96B7A8D67A}" type="datetimeFigureOut">
               <a:rPr lang="en-US" smtClean="0"/>
-              <a:t>10/24/2022</a:t>
+              <a:t>10/25/2022</a:t>
             </a:fld>
             <a:endParaRPr lang="en-US"/>
           </a:p>
@@ -2342,7 +2340,7 @@
           <a:p>
             <a:fld id="{A7DB5662-7327-465C-9A70-AD96B7A8D67A}" type="datetimeFigureOut">
               <a:rPr lang="en-US" smtClean="0"/>
-              <a:t>10/24/2022</a:t>
+              <a:t>10/25/2022</a:t>
             </a:fld>
             <a:endParaRPr lang="en-US"/>
           </a:p>
@@ -2455,7 +2453,7 @@
           <a:p>
             <a:fld id="{A7DB5662-7327-465C-9A70-AD96B7A8D67A}" type="datetimeFigureOut">
               <a:rPr lang="en-US" smtClean="0"/>
-              <a:t>10/24/2022</a:t>
+              <a:t>10/25/2022</a:t>
             </a:fld>
             <a:endParaRPr lang="en-US"/>
           </a:p>
@@ -2766,7 +2764,7 @@
           <a:p>
             <a:fld id="{A7DB5662-7327-465C-9A70-AD96B7A8D67A}" type="datetimeFigureOut">
               <a:rPr lang="en-US" smtClean="0"/>
-              <a:t>10/24/2022</a:t>
+              <a:t>10/25/2022</a:t>
             </a:fld>
             <a:endParaRPr lang="en-US"/>
           </a:p>
@@ -3054,7 +3052,7 @@
           <a:p>
             <a:fld id="{A7DB5662-7327-465C-9A70-AD96B7A8D67A}" type="datetimeFigureOut">
               <a:rPr lang="en-US" smtClean="0"/>
-              <a:t>10/24/2022</a:t>
+              <a:t>10/25/2022</a:t>
             </a:fld>
             <a:endParaRPr lang="en-US"/>
           </a:p>
@@ -3295,7 +3293,7 @@
           <a:p>
             <a:fld id="{A7DB5662-7327-465C-9A70-AD96B7A8D67A}" type="datetimeFigureOut">
               <a:rPr lang="en-US" smtClean="0"/>
-              <a:t>10/24/2022</a:t>
+              <a:t>10/25/2022</a:t>
             </a:fld>
             <a:endParaRPr lang="en-US"/>
           </a:p>
@@ -25330,8 +25328,8 @@
           </a:p>
         </p:txBody>
       </p:sp>
-      <mc:AlternateContent xmlns:mc="http://schemas.openxmlformats.org/markup-compatibility/2006">
-        <mc:Choice xmlns:a14="http://schemas.microsoft.com/office/drawing/2010/main" Requires="a14">
+      <mc:AlternateContent xmlns:mc="http://schemas.openxmlformats.org/markup-compatibility/2006" xmlns:a14="http://schemas.microsoft.com/office/drawing/2010/main">
+        <mc:Choice Requires="a14">
           <p:sp>
             <p:nvSpPr>
               <p:cNvPr id="3" name="Content Placeholder 2">
@@ -25843,7 +25841,7 @@
             </p:txBody>
           </p:sp>
         </mc:Choice>
-        <mc:Fallback>
+        <mc:Fallback xmlns="">
           <p:sp>
             <p:nvSpPr>
               <p:cNvPr id="3" name="Content Placeholder 2">
@@ -27549,542 +27547,6 @@
               <a:rPr lang="en-US" sz="2000" dirty="0">
                 <a:latin typeface="+mj-lt"/>
               </a:rPr>
-              <a:t>Imagine a task consisting in classifying patients into COVID infected or not. The algorithm will perform well if</a:t>
-            </a:r>
-          </a:p>
-          <a:p>
-            <a:pPr lvl="1">
-              <a:lnSpc>
-                <a:spcPct val="100000"/>
-              </a:lnSpc>
-              <a:buFont typeface="Wingdings" panose="05000000000000000000" pitchFamily="2" charset="2"/>
-              <a:buChar char="§"/>
-            </a:pPr>
-            <a:r>
-              <a:rPr lang="en-US" sz="1600" dirty="0">
-                <a:latin typeface="+mj-lt"/>
-              </a:rPr>
-              <a:t>Classifies as infected individuals that do have the disease </a:t>
-            </a:r>
-          </a:p>
-          <a:p>
-            <a:pPr lvl="1">
-              <a:lnSpc>
-                <a:spcPct val="100000"/>
-              </a:lnSpc>
-              <a:buFont typeface="Wingdings" panose="05000000000000000000" pitchFamily="2" charset="2"/>
-              <a:buChar char="§"/>
-            </a:pPr>
-            <a:r>
-              <a:rPr lang="en-US" sz="1600" dirty="0">
-                <a:latin typeface="+mj-lt"/>
-              </a:rPr>
-              <a:t>Classifies as not infected individuals that do not have the disease. </a:t>
-            </a:r>
-          </a:p>
-          <a:p>
-            <a:pPr lvl="1">
-              <a:lnSpc>
-                <a:spcPct val="100000"/>
-              </a:lnSpc>
-              <a:buFont typeface="Wingdings" panose="05000000000000000000" pitchFamily="2" charset="2"/>
-              <a:buChar char="§"/>
-            </a:pPr>
-            <a:r>
-              <a:rPr lang="en-US" sz="1600" dirty="0">
-                <a:latin typeface="+mj-lt"/>
-              </a:rPr>
-              <a:t>Do not classify as infected a person that is totally healthy</a:t>
-            </a:r>
-          </a:p>
-          <a:p>
-            <a:pPr lvl="1">
-              <a:lnSpc>
-                <a:spcPct val="100000"/>
-              </a:lnSpc>
-              <a:buFont typeface="Wingdings" panose="05000000000000000000" pitchFamily="2" charset="2"/>
-              <a:buChar char="§"/>
-            </a:pPr>
-            <a:r>
-              <a:rPr lang="en-US" sz="1600" dirty="0">
-                <a:latin typeface="+mj-lt"/>
-              </a:rPr>
-              <a:t>Do not classify as not infected a person that is actually sick</a:t>
-            </a:r>
-          </a:p>
-          <a:p>
-            <a:pPr>
-              <a:lnSpc>
-                <a:spcPct val="100000"/>
-              </a:lnSpc>
-              <a:buFont typeface="Wingdings" panose="05000000000000000000" pitchFamily="2" charset="2"/>
-              <a:buChar char="§"/>
-            </a:pPr>
-            <a:endParaRPr lang="en-US" sz="2000" dirty="0">
-              <a:latin typeface="+mj-lt"/>
-            </a:endParaRPr>
-          </a:p>
-        </p:txBody>
-      </p:sp>
-    </p:spTree>
-    <p:extLst>
-      <p:ext uri="{BB962C8B-B14F-4D97-AF65-F5344CB8AC3E}">
-        <p14:creationId xmlns:p14="http://schemas.microsoft.com/office/powerpoint/2010/main" val="2711951963"/>
-      </p:ext>
-    </p:extLst>
-  </p:cSld>
-  <p:clrMapOvr>
-    <a:masterClrMapping/>
-  </p:clrMapOvr>
-</p:sld>
-</file>
-
-<file path=ppt/slides/slide18.xml><?xml version="1.0" encoding="utf-8"?>
-<p:sld xmlns:a="http://schemas.openxmlformats.org/drawingml/2006/main" xmlns:r="http://schemas.openxmlformats.org/officeDocument/2006/relationships" xmlns:p="http://schemas.openxmlformats.org/presentationml/2006/main">
-  <p:cSld>
-    <p:spTree>
-      <p:nvGrpSpPr>
-        <p:cNvPr id="1" name=""/>
-        <p:cNvGrpSpPr/>
-        <p:nvPr/>
-      </p:nvGrpSpPr>
-      <p:grpSpPr>
-        <a:xfrm>
-          <a:off x="0" y="0"/>
-          <a:ext cx="0" cy="0"/>
-          <a:chOff x="0" y="0"/>
-          <a:chExt cx="0" cy="0"/>
-        </a:xfrm>
-      </p:grpSpPr>
-      <p:sp>
-        <p:nvSpPr>
-          <p:cNvPr id="2" name="Title 1">
-            <a:extLst>
-              <a:ext uri="{FF2B5EF4-FFF2-40B4-BE49-F238E27FC236}">
-                <a16:creationId xmlns:a16="http://schemas.microsoft.com/office/drawing/2014/main" id="{15C869D5-4E6C-6766-7E06-98B25E955D87}"/>
-              </a:ext>
-            </a:extLst>
-          </p:cNvPr>
-          <p:cNvSpPr>
-            <a:spLocks noGrp="1"/>
-          </p:cNvSpPr>
-          <p:nvPr>
-            <p:ph type="title"/>
-          </p:nvPr>
-        </p:nvSpPr>
-        <p:spPr/>
-        <p:txBody>
-          <a:bodyPr>
-            <a:normAutofit/>
-          </a:bodyPr>
-          <a:lstStyle/>
-          <a:p>
-            <a:r>
-              <a:rPr lang="en-US" sz="4000" dirty="0"/>
-              <a:t>Performance measures</a:t>
-            </a:r>
-          </a:p>
-        </p:txBody>
-      </p:sp>
-      <p:sp>
-        <p:nvSpPr>
-          <p:cNvPr id="4" name="Rectángulo 3">
-            <a:extLst>
-              <a:ext uri="{FF2B5EF4-FFF2-40B4-BE49-F238E27FC236}">
-                <a16:creationId xmlns:a16="http://schemas.microsoft.com/office/drawing/2014/main" id="{27E372AA-1ACE-5D2D-EDED-66DB6F5F4F88}"/>
-              </a:ext>
-            </a:extLst>
-          </p:cNvPr>
-          <p:cNvSpPr/>
-          <p:nvPr/>
-        </p:nvSpPr>
-        <p:spPr>
-          <a:xfrm>
-            <a:off x="0" y="0"/>
-            <a:ext cx="374469" cy="6858000"/>
-          </a:xfrm>
-          <a:prstGeom prst="rect">
-            <a:avLst/>
-          </a:prstGeom>
-        </p:spPr>
-        <p:style>
-          <a:lnRef idx="2">
-            <a:schemeClr val="accent2">
-              <a:shade val="50000"/>
-            </a:schemeClr>
-          </a:lnRef>
-          <a:fillRef idx="1">
-            <a:schemeClr val="accent2"/>
-          </a:fillRef>
-          <a:effectRef idx="0">
-            <a:schemeClr val="accent2"/>
-          </a:effectRef>
-          <a:fontRef idx="minor">
-            <a:schemeClr val="lt1"/>
-          </a:fontRef>
-        </p:style>
-        <p:txBody>
-          <a:bodyPr rtlCol="0" anchor="ctr"/>
-          <a:lstStyle/>
-          <a:p>
-            <a:pPr algn="ctr"/>
-            <a:endParaRPr lang="es-ES"/>
-          </a:p>
-        </p:txBody>
-      </p:sp>
-      <p:sp>
-        <p:nvSpPr>
-          <p:cNvPr id="5" name="Rectangle 143">
-            <a:extLst>
-              <a:ext uri="{FF2B5EF4-FFF2-40B4-BE49-F238E27FC236}">
-                <a16:creationId xmlns:a16="http://schemas.microsoft.com/office/drawing/2014/main" id="{4CAC6C5C-8798-AF6F-C852-967659577BF3}"/>
-              </a:ext>
-            </a:extLst>
-          </p:cNvPr>
-          <p:cNvSpPr>
-            <a:spLocks noChangeArrowheads="1"/>
-          </p:cNvSpPr>
-          <p:nvPr/>
-        </p:nvSpPr>
-        <p:spPr bwMode="auto">
-          <a:xfrm>
-            <a:off x="448342" y="6482412"/>
-            <a:ext cx="5730175" cy="276999"/>
-          </a:xfrm>
-          <a:prstGeom prst="rect">
-            <a:avLst/>
-          </a:prstGeom>
-          <a:noFill/>
-          <a:ln>
-            <a:noFill/>
-          </a:ln>
-          <a:effectLst/>
-          <a:extLst>
-            <a:ext uri="{909E8E84-426E-40DD-AFC4-6F175D3DCCD1}">
-              <a14:hiddenFill xmlns:a14="http://schemas.microsoft.com/office/drawing/2010/main">
-                <a:solidFill>
-                  <a:schemeClr val="accent1"/>
-                </a:solidFill>
-              </a14:hiddenFill>
-            </a:ext>
-            <a:ext uri="{91240B29-F687-4F45-9708-019B960494DF}">
-              <a14:hiddenLine xmlns:a14="http://schemas.microsoft.com/office/drawing/2010/main" w="9525">
-                <a:solidFill>
-                  <a:schemeClr val="tx1"/>
-                </a:solidFill>
-                <a:miter lim="800000"/>
-                <a:headEnd/>
-                <a:tailEnd/>
-              </a14:hiddenLine>
-            </a:ext>
-            <a:ext uri="{AF507438-7753-43E0-B8FC-AC1667EBCBE1}">
-              <a14:hiddenEffects xmlns:a14="http://schemas.microsoft.com/office/drawing/2010/main">
-                <a:effectLst>
-                  <a:outerShdw dist="35921" dir="2700000" algn="ctr" rotWithShape="0">
-                    <a:schemeClr val="bg2"/>
-                  </a:outerShdw>
-                </a:effectLst>
-              </a14:hiddenEffects>
-            </a:ext>
-          </a:extLst>
-        </p:spPr>
-        <p:txBody>
-          <a:bodyPr vert="horz" wrap="square" lIns="91440" tIns="45720" rIns="91440" bIns="45720" numCol="1" anchor="ctr" anchorCtr="0" compatLnSpc="1">
-            <a:prstTxWarp prst="textNoShape">
-              <a:avLst/>
-            </a:prstTxWarp>
-            <a:spAutoFit/>
-          </a:bodyPr>
-          <a:lstStyle/>
-          <a:p>
-            <a:pPr marL="0" marR="0" lvl="0" indent="0" algn="l" defTabSz="914400" rtl="0" eaLnBrk="0" fontAlgn="base" latinLnBrk="0" hangingPunct="0">
-              <a:lnSpc>
-                <a:spcPct val="100000"/>
-              </a:lnSpc>
-              <a:spcBef>
-                <a:spcPct val="0"/>
-              </a:spcBef>
-              <a:spcAft>
-                <a:spcPct val="0"/>
-              </a:spcAft>
-              <a:buClrTx/>
-              <a:buSzTx/>
-              <a:buFontTx/>
-              <a:buNone/>
-              <a:tabLst/>
-            </a:pPr>
-            <a:r>
-              <a:rPr kumimoji="0" lang="en-US" altLang="es-ES" sz="1200" b="0" i="0" u="none" strike="noStrike" cap="none" normalizeH="0" baseline="0" dirty="0">
-                <a:ln>
-                  <a:noFill/>
-                </a:ln>
-                <a:solidFill>
-                  <a:srgbClr val="F4A200"/>
-                </a:solidFill>
-                <a:effectLst/>
-                <a:latin typeface="Arial" panose="020B0604020202020204" pitchFamily="34" charset="0"/>
-                <a:ea typeface="Myriad Pro Light"/>
-                <a:cs typeface="Times New Roman" panose="02020603050405020304" pitchFamily="18" charset="0"/>
-              </a:rPr>
-              <a:t>Master in Quantitative Economic Analysis </a:t>
-            </a:r>
-            <a:r>
-              <a:rPr kumimoji="0" lang="en-US" altLang="es-ES" sz="1200" b="0" i="0" u="none" strike="noStrike" cap="none" normalizeH="0" baseline="0" dirty="0" err="1">
-                <a:ln>
-                  <a:noFill/>
-                </a:ln>
-                <a:solidFill>
-                  <a:srgbClr val="F4A200"/>
-                </a:solidFill>
-                <a:effectLst/>
-                <a:latin typeface="Arial" panose="020B0604020202020204" pitchFamily="34" charset="0"/>
-                <a:ea typeface="Myriad Pro Light"/>
-                <a:cs typeface="Times New Roman" panose="02020603050405020304" pitchFamily="18" charset="0"/>
-              </a:rPr>
-              <a:t>MQuEA</a:t>
-            </a:r>
-            <a:endParaRPr kumimoji="0" lang="es-ES" altLang="es-ES" sz="400" b="0" i="0" u="none" strike="noStrike" cap="none" normalizeH="0" baseline="0" dirty="0">
-              <a:ln>
-                <a:noFill/>
-              </a:ln>
-              <a:solidFill>
-                <a:schemeClr val="tx1"/>
-              </a:solidFill>
-              <a:effectLst/>
-              <a:latin typeface="Arial" panose="020B0604020202020204" pitchFamily="34" charset="0"/>
-            </a:endParaRPr>
-          </a:p>
-        </p:txBody>
-      </p:sp>
-      <p:sp>
-        <p:nvSpPr>
-          <p:cNvPr id="6" name="Rectangle 143">
-            <a:extLst>
-              <a:ext uri="{FF2B5EF4-FFF2-40B4-BE49-F238E27FC236}">
-                <a16:creationId xmlns:a16="http://schemas.microsoft.com/office/drawing/2014/main" id="{09E0FB32-C00A-A390-E094-76FC3EA5C288}"/>
-              </a:ext>
-            </a:extLst>
-          </p:cNvPr>
-          <p:cNvSpPr>
-            <a:spLocks noChangeArrowheads="1"/>
-          </p:cNvSpPr>
-          <p:nvPr/>
-        </p:nvSpPr>
-        <p:spPr bwMode="auto">
-          <a:xfrm>
-            <a:off x="6186394" y="6493050"/>
-            <a:ext cx="5730175" cy="276999"/>
-          </a:xfrm>
-          <a:prstGeom prst="rect">
-            <a:avLst/>
-          </a:prstGeom>
-          <a:noFill/>
-          <a:ln>
-            <a:noFill/>
-          </a:ln>
-          <a:effectLst/>
-          <a:extLst>
-            <a:ext uri="{909E8E84-426E-40DD-AFC4-6F175D3DCCD1}">
-              <a14:hiddenFill xmlns:a14="http://schemas.microsoft.com/office/drawing/2010/main">
-                <a:solidFill>
-                  <a:schemeClr val="accent1"/>
-                </a:solidFill>
-              </a14:hiddenFill>
-            </a:ext>
-            <a:ext uri="{91240B29-F687-4F45-9708-019B960494DF}">
-              <a14:hiddenLine xmlns:a14="http://schemas.microsoft.com/office/drawing/2010/main" w="9525">
-                <a:solidFill>
-                  <a:schemeClr val="tx1"/>
-                </a:solidFill>
-                <a:miter lim="800000"/>
-                <a:headEnd/>
-                <a:tailEnd/>
-              </a14:hiddenLine>
-            </a:ext>
-            <a:ext uri="{AF507438-7753-43E0-B8FC-AC1667EBCBE1}">
-              <a14:hiddenEffects xmlns:a14="http://schemas.microsoft.com/office/drawing/2010/main">
-                <a:effectLst>
-                  <a:outerShdw dist="35921" dir="2700000" algn="ctr" rotWithShape="0">
-                    <a:schemeClr val="bg2"/>
-                  </a:outerShdw>
-                </a:effectLst>
-              </a14:hiddenEffects>
-            </a:ext>
-          </a:extLst>
-        </p:spPr>
-        <p:txBody>
-          <a:bodyPr vert="horz" wrap="square" lIns="91440" tIns="45720" rIns="91440" bIns="45720" numCol="1" anchor="ctr" anchorCtr="0" compatLnSpc="1">
-            <a:prstTxWarp prst="textNoShape">
-              <a:avLst/>
-            </a:prstTxWarp>
-            <a:spAutoFit/>
-          </a:bodyPr>
-          <a:lstStyle/>
-          <a:p>
-            <a:pPr marL="0" marR="0" lvl="0" indent="0" algn="r" defTabSz="914400" rtl="0" eaLnBrk="0" fontAlgn="base" latinLnBrk="0" hangingPunct="0">
-              <a:lnSpc>
-                <a:spcPct val="100000"/>
-              </a:lnSpc>
-              <a:spcBef>
-                <a:spcPct val="0"/>
-              </a:spcBef>
-              <a:spcAft>
-                <a:spcPct val="0"/>
-              </a:spcAft>
-              <a:buClrTx/>
-              <a:buSzTx/>
-              <a:buFontTx/>
-              <a:buNone/>
-              <a:tabLst/>
-            </a:pPr>
-            <a:r>
-              <a:rPr kumimoji="0" lang="en-US" altLang="es-ES" sz="1200" b="0" i="0" u="none" strike="noStrike" cap="none" normalizeH="0" baseline="0" dirty="0">
-                <a:ln>
-                  <a:noFill/>
-                </a:ln>
-                <a:solidFill>
-                  <a:srgbClr val="F4A200"/>
-                </a:solidFill>
-                <a:effectLst/>
-                <a:latin typeface="Arial" panose="020B0604020202020204" pitchFamily="34" charset="0"/>
-                <a:ea typeface="Myriad Pro Light"/>
-                <a:cs typeface="Times New Roman" panose="02020603050405020304" pitchFamily="18" charset="0"/>
-              </a:rPr>
-              <a:t>Universidad </a:t>
-            </a:r>
-            <a:r>
-              <a:rPr kumimoji="0" lang="en-US" altLang="es-ES" sz="1200" b="0" i="0" u="none" strike="noStrike" cap="none" normalizeH="0" baseline="0" dirty="0" err="1">
-                <a:ln>
-                  <a:noFill/>
-                </a:ln>
-                <a:solidFill>
-                  <a:srgbClr val="F4A200"/>
-                </a:solidFill>
-                <a:effectLst/>
-                <a:latin typeface="Arial" panose="020B0604020202020204" pitchFamily="34" charset="0"/>
-                <a:ea typeface="Myriad Pro Light"/>
-                <a:cs typeface="Times New Roman" panose="02020603050405020304" pitchFamily="18" charset="0"/>
-              </a:rPr>
-              <a:t>Aut</a:t>
-            </a:r>
-            <a:r>
-              <a:rPr lang="en-US" altLang="es-ES" sz="1200" dirty="0" err="1">
-                <a:solidFill>
-                  <a:srgbClr val="F4A200"/>
-                </a:solidFill>
-                <a:latin typeface="Arial" panose="020B0604020202020204" pitchFamily="34" charset="0"/>
-                <a:ea typeface="Myriad Pro Light"/>
-                <a:cs typeface="Times New Roman" panose="02020603050405020304" pitchFamily="18" charset="0"/>
-              </a:rPr>
-              <a:t>ó</a:t>
-            </a:r>
-            <a:r>
-              <a:rPr kumimoji="0" lang="en-US" altLang="es-ES" sz="1200" b="0" i="0" u="none" strike="noStrike" cap="none" normalizeH="0" baseline="0" dirty="0" err="1">
-                <a:ln>
-                  <a:noFill/>
-                </a:ln>
-                <a:solidFill>
-                  <a:srgbClr val="F4A200"/>
-                </a:solidFill>
-                <a:effectLst/>
-                <a:latin typeface="Arial" panose="020B0604020202020204" pitchFamily="34" charset="0"/>
-                <a:ea typeface="Myriad Pro Light"/>
-                <a:cs typeface="Times New Roman" panose="02020603050405020304" pitchFamily="18" charset="0"/>
-              </a:rPr>
-              <a:t>noma</a:t>
-            </a:r>
-            <a:r>
-              <a:rPr kumimoji="0" lang="en-US" altLang="es-ES" sz="1200" b="0" i="0" u="none" strike="noStrike" cap="none" normalizeH="0" baseline="0" dirty="0">
-                <a:ln>
-                  <a:noFill/>
-                </a:ln>
-                <a:solidFill>
-                  <a:srgbClr val="F4A200"/>
-                </a:solidFill>
-                <a:effectLst/>
-                <a:latin typeface="Arial" panose="020B0604020202020204" pitchFamily="34" charset="0"/>
-                <a:ea typeface="Myriad Pro Light"/>
-                <a:cs typeface="Times New Roman" panose="02020603050405020304" pitchFamily="18" charset="0"/>
-              </a:rPr>
-              <a:t> de Madrid</a:t>
-            </a:r>
-            <a:endParaRPr kumimoji="0" lang="es-ES" altLang="es-ES" sz="400" b="0" i="0" u="none" strike="noStrike" cap="none" normalizeH="0" baseline="0" dirty="0">
-              <a:ln>
-                <a:noFill/>
-              </a:ln>
-              <a:solidFill>
-                <a:schemeClr val="tx1"/>
-              </a:solidFill>
-              <a:effectLst/>
-              <a:latin typeface="Arial" panose="020B0604020202020204" pitchFamily="34" charset="0"/>
-            </a:endParaRPr>
-          </a:p>
-        </p:txBody>
-      </p:sp>
-      <p:sp>
-        <p:nvSpPr>
-          <p:cNvPr id="3" name="Content Placeholder 2">
-            <a:extLst>
-              <a:ext uri="{FF2B5EF4-FFF2-40B4-BE49-F238E27FC236}">
-                <a16:creationId xmlns:a16="http://schemas.microsoft.com/office/drawing/2014/main" id="{F7EF27C5-01B7-9F60-ECDA-A1F376586FC5}"/>
-              </a:ext>
-            </a:extLst>
-          </p:cNvPr>
-          <p:cNvSpPr>
-            <a:spLocks noGrp="1"/>
-          </p:cNvSpPr>
-          <p:nvPr>
-            <p:ph idx="1"/>
-          </p:nvPr>
-        </p:nvSpPr>
-        <p:spPr/>
-        <p:txBody>
-          <a:bodyPr>
-            <a:normAutofit/>
-          </a:bodyPr>
-          <a:lstStyle/>
-          <a:p>
-            <a:pPr>
-              <a:lnSpc>
-                <a:spcPct val="100000"/>
-              </a:lnSpc>
-              <a:buFont typeface="Wingdings" panose="05000000000000000000" pitchFamily="2" charset="2"/>
-              <a:buChar char="§"/>
-            </a:pPr>
-            <a:r>
-              <a:rPr lang="en-US" sz="2000" dirty="0">
-                <a:latin typeface="+mj-lt"/>
-              </a:rPr>
-              <a:t>To evaluate a regression, one only needs to pay attention to the performance measure (the lower, the better). But assessing performance in a classification is bit more nuance.</a:t>
-            </a:r>
-          </a:p>
-          <a:p>
-            <a:pPr>
-              <a:lnSpc>
-                <a:spcPct val="100000"/>
-              </a:lnSpc>
-              <a:buFont typeface="Wingdings" panose="05000000000000000000" pitchFamily="2" charset="2"/>
-              <a:buChar char="§"/>
-            </a:pPr>
-            <a:r>
-              <a:rPr lang="en-US" sz="2000" dirty="0">
-                <a:latin typeface="+mj-lt"/>
-              </a:rPr>
-              <a:t>Just looking for a better accuracy (% of correct predictions) is not enough…</a:t>
-            </a:r>
-          </a:p>
-          <a:p>
-            <a:pPr>
-              <a:lnSpc>
-                <a:spcPct val="100000"/>
-              </a:lnSpc>
-              <a:buFont typeface="Wingdings" panose="05000000000000000000" pitchFamily="2" charset="2"/>
-              <a:buChar char="§"/>
-            </a:pPr>
-            <a:r>
-              <a:rPr lang="en-US" sz="2000" dirty="0">
-                <a:latin typeface="+mj-lt"/>
-              </a:rPr>
               <a:t>Imagine a task consisting in classifying patients into COVID-19 infected or not. The algorithm will perform well if:</a:t>
             </a:r>
           </a:p>
@@ -28175,7 +27637,7 @@
 </p:sld>
 </file>
 
-<file path=ppt/slides/slide19.xml><?xml version="1.0" encoding="utf-8"?>
+<file path=ppt/slides/slide18.xml><?xml version="1.0" encoding="utf-8"?>
 <p:sld xmlns:a="http://schemas.openxmlformats.org/drawingml/2006/main" xmlns:r="http://schemas.openxmlformats.org/officeDocument/2006/relationships" xmlns:p="http://schemas.openxmlformats.org/presentationml/2006/main">
   <p:cSld>
     <p:spTree>
@@ -29098,850 +28560,7 @@
 </p:sld>
 </file>
 
-<file path=ppt/slides/slide2.xml><?xml version="1.0" encoding="utf-8"?>
-<p:sld xmlns:a="http://schemas.openxmlformats.org/drawingml/2006/main" xmlns:r="http://schemas.openxmlformats.org/officeDocument/2006/relationships" xmlns:p="http://schemas.openxmlformats.org/presentationml/2006/main">
-  <p:cSld>
-    <p:spTree>
-      <p:nvGrpSpPr>
-        <p:cNvPr id="1" name=""/>
-        <p:cNvGrpSpPr/>
-        <p:nvPr/>
-      </p:nvGrpSpPr>
-      <p:grpSpPr>
-        <a:xfrm>
-          <a:off x="0" y="0"/>
-          <a:ext cx="0" cy="0"/>
-          <a:chOff x="0" y="0"/>
-          <a:chExt cx="0" cy="0"/>
-        </a:xfrm>
-      </p:grpSpPr>
-      <p:sp>
-        <p:nvSpPr>
-          <p:cNvPr id="4" name="Rectángulo 3">
-            <a:extLst>
-              <a:ext uri="{FF2B5EF4-FFF2-40B4-BE49-F238E27FC236}">
-                <a16:creationId xmlns:a16="http://schemas.microsoft.com/office/drawing/2014/main" id="{DAB19569-A64F-C399-1542-792E0E4616AC}"/>
-              </a:ext>
-            </a:extLst>
-          </p:cNvPr>
-          <p:cNvSpPr/>
-          <p:nvPr/>
-        </p:nvSpPr>
-        <p:spPr>
-          <a:xfrm>
-            <a:off x="0" y="0"/>
-            <a:ext cx="374469" cy="6858000"/>
-          </a:xfrm>
-          <a:prstGeom prst="rect">
-            <a:avLst/>
-          </a:prstGeom>
-        </p:spPr>
-        <p:style>
-          <a:lnRef idx="2">
-            <a:schemeClr val="accent2">
-              <a:shade val="50000"/>
-            </a:schemeClr>
-          </a:lnRef>
-          <a:fillRef idx="1">
-            <a:schemeClr val="accent2"/>
-          </a:fillRef>
-          <a:effectRef idx="0">
-            <a:schemeClr val="accent2"/>
-          </a:effectRef>
-          <a:fontRef idx="minor">
-            <a:schemeClr val="lt1"/>
-          </a:fontRef>
-        </p:style>
-        <p:txBody>
-          <a:bodyPr rtlCol="0" anchor="ctr"/>
-          <a:lstStyle/>
-          <a:p>
-            <a:pPr algn="ctr"/>
-            <a:endParaRPr lang="es-ES"/>
-          </a:p>
-        </p:txBody>
-      </p:sp>
-      <p:sp>
-        <p:nvSpPr>
-          <p:cNvPr id="152" name="Content Placeholder 2">
-            <a:extLst>
-              <a:ext uri="{FF2B5EF4-FFF2-40B4-BE49-F238E27FC236}">
-                <a16:creationId xmlns:a16="http://schemas.microsoft.com/office/drawing/2014/main" id="{B7719AE7-5D76-3CA6-C03E-F772C1896EF4}"/>
-              </a:ext>
-            </a:extLst>
-          </p:cNvPr>
-          <p:cNvSpPr txBox="1">
-            <a:spLocks/>
-          </p:cNvSpPr>
-          <p:nvPr/>
-        </p:nvSpPr>
-        <p:spPr>
-          <a:xfrm>
-            <a:off x="1494790" y="1875615"/>
-            <a:ext cx="9859010" cy="4351338"/>
-          </a:xfrm>
-          <a:prstGeom prst="rect">
-            <a:avLst/>
-          </a:prstGeom>
-        </p:spPr>
-        <p:txBody>
-          <a:bodyPr vert="horz" lIns="91440" tIns="45720" rIns="91440" bIns="45720" rtlCol="0">
-            <a:normAutofit fontScale="92500" lnSpcReduction="10000"/>
-          </a:bodyPr>
-          <a:lstStyle>
-            <a:lvl1pPr marL="0" indent="0" algn="ctr" defTabSz="914400" rtl="0" eaLnBrk="1" latinLnBrk="0" hangingPunct="1">
-              <a:lnSpc>
-                <a:spcPct val="90000"/>
-              </a:lnSpc>
-              <a:spcBef>
-                <a:spcPts val="1000"/>
-              </a:spcBef>
-              <a:buFont typeface="Arial" panose="020B0604020202020204" pitchFamily="34" charset="0"/>
-              <a:buNone/>
-              <a:defRPr sz="2400" kern="1200">
-                <a:solidFill>
-                  <a:schemeClr val="tx1"/>
-                </a:solidFill>
-                <a:latin typeface="+mn-lt"/>
-                <a:ea typeface="+mn-ea"/>
-                <a:cs typeface="+mn-cs"/>
-              </a:defRPr>
-            </a:lvl1pPr>
-            <a:lvl2pPr marL="457200" indent="0" algn="ctr" defTabSz="914400" rtl="0" eaLnBrk="1" latinLnBrk="0" hangingPunct="1">
-              <a:lnSpc>
-                <a:spcPct val="90000"/>
-              </a:lnSpc>
-              <a:spcBef>
-                <a:spcPts val="500"/>
-              </a:spcBef>
-              <a:buFont typeface="Arial" panose="020B0604020202020204" pitchFamily="34" charset="0"/>
-              <a:buNone/>
-              <a:defRPr sz="2000" kern="1200">
-                <a:solidFill>
-                  <a:schemeClr val="tx1"/>
-                </a:solidFill>
-                <a:latin typeface="+mn-lt"/>
-                <a:ea typeface="+mn-ea"/>
-                <a:cs typeface="+mn-cs"/>
-              </a:defRPr>
-            </a:lvl2pPr>
-            <a:lvl3pPr marL="914400" indent="0" algn="ctr" defTabSz="914400" rtl="0" eaLnBrk="1" latinLnBrk="0" hangingPunct="1">
-              <a:lnSpc>
-                <a:spcPct val="90000"/>
-              </a:lnSpc>
-              <a:spcBef>
-                <a:spcPts val="500"/>
-              </a:spcBef>
-              <a:buFont typeface="Arial" panose="020B0604020202020204" pitchFamily="34" charset="0"/>
-              <a:buNone/>
-              <a:defRPr sz="1800" kern="1200">
-                <a:solidFill>
-                  <a:schemeClr val="tx1"/>
-                </a:solidFill>
-                <a:latin typeface="+mn-lt"/>
-                <a:ea typeface="+mn-ea"/>
-                <a:cs typeface="+mn-cs"/>
-              </a:defRPr>
-            </a:lvl3pPr>
-            <a:lvl4pPr marL="1371600" indent="0" algn="ctr" defTabSz="914400" rtl="0" eaLnBrk="1" latinLnBrk="0" hangingPunct="1">
-              <a:lnSpc>
-                <a:spcPct val="90000"/>
-              </a:lnSpc>
-              <a:spcBef>
-                <a:spcPts val="500"/>
-              </a:spcBef>
-              <a:buFont typeface="Arial" panose="020B0604020202020204" pitchFamily="34" charset="0"/>
-              <a:buNone/>
-              <a:defRPr sz="1600" kern="1200">
-                <a:solidFill>
-                  <a:schemeClr val="tx1"/>
-                </a:solidFill>
-                <a:latin typeface="+mn-lt"/>
-                <a:ea typeface="+mn-ea"/>
-                <a:cs typeface="+mn-cs"/>
-              </a:defRPr>
-            </a:lvl4pPr>
-            <a:lvl5pPr marL="1828800" indent="0" algn="ctr" defTabSz="914400" rtl="0" eaLnBrk="1" latinLnBrk="0" hangingPunct="1">
-              <a:lnSpc>
-                <a:spcPct val="90000"/>
-              </a:lnSpc>
-              <a:spcBef>
-                <a:spcPts val="500"/>
-              </a:spcBef>
-              <a:buFont typeface="Arial" panose="020B0604020202020204" pitchFamily="34" charset="0"/>
-              <a:buNone/>
-              <a:defRPr sz="1600" kern="1200">
-                <a:solidFill>
-                  <a:schemeClr val="tx1"/>
-                </a:solidFill>
-                <a:latin typeface="+mn-lt"/>
-                <a:ea typeface="+mn-ea"/>
-                <a:cs typeface="+mn-cs"/>
-              </a:defRPr>
-            </a:lvl5pPr>
-            <a:lvl6pPr marL="2286000" indent="0" algn="ctr" defTabSz="914400" rtl="0" eaLnBrk="1" latinLnBrk="0" hangingPunct="1">
-              <a:lnSpc>
-                <a:spcPct val="90000"/>
-              </a:lnSpc>
-              <a:spcBef>
-                <a:spcPts val="500"/>
-              </a:spcBef>
-              <a:buFont typeface="Arial" panose="020B0604020202020204" pitchFamily="34" charset="0"/>
-              <a:buNone/>
-              <a:defRPr sz="1600" kern="1200">
-                <a:solidFill>
-                  <a:schemeClr val="tx1"/>
-                </a:solidFill>
-                <a:latin typeface="+mn-lt"/>
-                <a:ea typeface="+mn-ea"/>
-                <a:cs typeface="+mn-cs"/>
-              </a:defRPr>
-            </a:lvl6pPr>
-            <a:lvl7pPr marL="2743200" indent="0" algn="ctr" defTabSz="914400" rtl="0" eaLnBrk="1" latinLnBrk="0" hangingPunct="1">
-              <a:lnSpc>
-                <a:spcPct val="90000"/>
-              </a:lnSpc>
-              <a:spcBef>
-                <a:spcPts val="500"/>
-              </a:spcBef>
-              <a:buFont typeface="Arial" panose="020B0604020202020204" pitchFamily="34" charset="0"/>
-              <a:buNone/>
-              <a:defRPr sz="1600" kern="1200">
-                <a:solidFill>
-                  <a:schemeClr val="tx1"/>
-                </a:solidFill>
-                <a:latin typeface="+mn-lt"/>
-                <a:ea typeface="+mn-ea"/>
-                <a:cs typeface="+mn-cs"/>
-              </a:defRPr>
-            </a:lvl7pPr>
-            <a:lvl8pPr marL="3200400" indent="0" algn="ctr" defTabSz="914400" rtl="0" eaLnBrk="1" latinLnBrk="0" hangingPunct="1">
-              <a:lnSpc>
-                <a:spcPct val="90000"/>
-              </a:lnSpc>
-              <a:spcBef>
-                <a:spcPts val="500"/>
-              </a:spcBef>
-              <a:buFont typeface="Arial" panose="020B0604020202020204" pitchFamily="34" charset="0"/>
-              <a:buNone/>
-              <a:defRPr sz="1600" kern="1200">
-                <a:solidFill>
-                  <a:schemeClr val="tx1"/>
-                </a:solidFill>
-                <a:latin typeface="+mn-lt"/>
-                <a:ea typeface="+mn-ea"/>
-                <a:cs typeface="+mn-cs"/>
-              </a:defRPr>
-            </a:lvl8pPr>
-            <a:lvl9pPr marL="3657600" indent="0" algn="ctr" defTabSz="914400" rtl="0" eaLnBrk="1" latinLnBrk="0" hangingPunct="1">
-              <a:lnSpc>
-                <a:spcPct val="90000"/>
-              </a:lnSpc>
-              <a:spcBef>
-                <a:spcPts val="500"/>
-              </a:spcBef>
-              <a:buFont typeface="Arial" panose="020B0604020202020204" pitchFamily="34" charset="0"/>
-              <a:buNone/>
-              <a:defRPr sz="1600" kern="1200">
-                <a:solidFill>
-                  <a:schemeClr val="tx1"/>
-                </a:solidFill>
-                <a:latin typeface="+mn-lt"/>
-                <a:ea typeface="+mn-ea"/>
-                <a:cs typeface="+mn-cs"/>
-              </a:defRPr>
-            </a:lvl9pPr>
-          </a:lstStyle>
-          <a:p>
-            <a:pPr marL="457200" indent="-457200" algn="l">
-              <a:lnSpc>
-                <a:spcPct val="100000"/>
-              </a:lnSpc>
-              <a:buFont typeface="Wingdings" panose="05000000000000000000" pitchFamily="2" charset="2"/>
-              <a:buChar char="§"/>
-            </a:pPr>
-            <a:r>
-              <a:rPr lang="en-US" sz="2800" dirty="0">
-                <a:latin typeface="+mj-lt"/>
-                <a:cs typeface="Times New Roman" panose="02020603050405020304" pitchFamily="18" charset="0"/>
-              </a:rPr>
-              <a:t>Classifying?</a:t>
-            </a:r>
-          </a:p>
-          <a:p>
-            <a:pPr marL="457200" indent="-457200" algn="l">
-              <a:lnSpc>
-                <a:spcPct val="100000"/>
-              </a:lnSpc>
-              <a:buFont typeface="Wingdings" panose="05000000000000000000" pitchFamily="2" charset="2"/>
-              <a:buChar char="§"/>
-            </a:pPr>
-            <a:r>
-              <a:rPr lang="en-US" sz="2800" dirty="0">
-                <a:latin typeface="+mj-lt"/>
-                <a:cs typeface="Times New Roman" panose="02020603050405020304" pitchFamily="18" charset="0"/>
-              </a:rPr>
-              <a:t>Classifiers</a:t>
-            </a:r>
-          </a:p>
-          <a:p>
-            <a:pPr marL="914400" lvl="1" indent="-457200" algn="l">
-              <a:lnSpc>
-                <a:spcPct val="100000"/>
-              </a:lnSpc>
-              <a:buFont typeface="Wingdings" panose="05000000000000000000" pitchFamily="2" charset="2"/>
-              <a:buChar char="§"/>
-            </a:pPr>
-            <a:r>
-              <a:rPr lang="en-US" sz="2400" dirty="0">
-                <a:latin typeface="+mj-lt"/>
-                <a:cs typeface="Times New Roman" panose="02020603050405020304" pitchFamily="18" charset="0"/>
-              </a:rPr>
-              <a:t>Logistic Regression</a:t>
-            </a:r>
-          </a:p>
-          <a:p>
-            <a:pPr marL="914400" lvl="1" indent="-457200" algn="l">
-              <a:lnSpc>
-                <a:spcPct val="100000"/>
-              </a:lnSpc>
-              <a:buFont typeface="Wingdings" panose="05000000000000000000" pitchFamily="2" charset="2"/>
-              <a:buChar char="§"/>
-            </a:pPr>
-            <a:r>
-              <a:rPr lang="en-US" sz="2400" dirty="0">
-                <a:latin typeface="+mj-lt"/>
-                <a:cs typeface="Times New Roman" panose="02020603050405020304" pitchFamily="18" charset="0"/>
-              </a:rPr>
-              <a:t>Linear discriminant analysis (LDA)</a:t>
-            </a:r>
-          </a:p>
-          <a:p>
-            <a:pPr marL="914400" lvl="1" indent="-457200" algn="l">
-              <a:lnSpc>
-                <a:spcPct val="100000"/>
-              </a:lnSpc>
-              <a:buFont typeface="Wingdings" panose="05000000000000000000" pitchFamily="2" charset="2"/>
-              <a:buChar char="§"/>
-            </a:pPr>
-            <a:r>
-              <a:rPr lang="en-US" sz="2400" dirty="0">
-                <a:latin typeface="+mj-lt"/>
-                <a:cs typeface="Times New Roman" panose="02020603050405020304" pitchFamily="18" charset="0"/>
-              </a:rPr>
-              <a:t>Stochastic Gradient Descent (SGD)</a:t>
-            </a:r>
-          </a:p>
-          <a:p>
-            <a:pPr marL="914400" lvl="1" indent="-457200" algn="l">
-              <a:lnSpc>
-                <a:spcPct val="100000"/>
-              </a:lnSpc>
-              <a:buFont typeface="Wingdings" panose="05000000000000000000" pitchFamily="2" charset="2"/>
-              <a:buChar char="§"/>
-            </a:pPr>
-            <a:r>
-              <a:rPr lang="en-US" sz="2400" dirty="0">
-                <a:latin typeface="+mj-lt"/>
-                <a:cs typeface="Times New Roman" panose="02020603050405020304" pitchFamily="18" charset="0"/>
-              </a:rPr>
-              <a:t>Support Vector Machines (SVM)</a:t>
-            </a:r>
-          </a:p>
-          <a:p>
-            <a:pPr marL="914400" lvl="1" indent="-457200" algn="l">
-              <a:lnSpc>
-                <a:spcPct val="100000"/>
-              </a:lnSpc>
-              <a:buFont typeface="Wingdings" panose="05000000000000000000" pitchFamily="2" charset="2"/>
-              <a:buChar char="§"/>
-            </a:pPr>
-            <a:r>
-              <a:rPr lang="en-US" sz="2400" i="1" dirty="0">
-                <a:latin typeface="+mj-lt"/>
-                <a:cs typeface="Times New Roman" panose="02020603050405020304" pitchFamily="18" charset="0"/>
-              </a:rPr>
-              <a:t>K</a:t>
-            </a:r>
-            <a:r>
-              <a:rPr lang="en-US" sz="2400" dirty="0">
-                <a:latin typeface="+mj-lt"/>
-                <a:cs typeface="Times New Roman" panose="02020603050405020304" pitchFamily="18" charset="0"/>
-              </a:rPr>
-              <a:t>-Nearest Neighbors (KNN)</a:t>
-            </a:r>
-            <a:endParaRPr lang="en-US" sz="2400" i="1" dirty="0">
-              <a:latin typeface="+mj-lt"/>
-              <a:cs typeface="Times New Roman" panose="02020603050405020304" pitchFamily="18" charset="0"/>
-            </a:endParaRPr>
-          </a:p>
-          <a:p>
-            <a:pPr marL="457200" indent="-457200" algn="l">
-              <a:lnSpc>
-                <a:spcPct val="100000"/>
-              </a:lnSpc>
-              <a:buFont typeface="Wingdings" panose="05000000000000000000" pitchFamily="2" charset="2"/>
-              <a:buChar char="§"/>
-            </a:pPr>
-            <a:r>
-              <a:rPr lang="en-US" sz="2800" dirty="0">
-                <a:latin typeface="+mj-lt"/>
-                <a:cs typeface="Times New Roman" panose="02020603050405020304" pitchFamily="18" charset="0"/>
-              </a:rPr>
-              <a:t>Performance measures</a:t>
-            </a:r>
-          </a:p>
-          <a:p>
-            <a:pPr marL="457200" indent="-457200" algn="l">
-              <a:lnSpc>
-                <a:spcPct val="100000"/>
-              </a:lnSpc>
-              <a:buFont typeface="Wingdings" panose="05000000000000000000" pitchFamily="2" charset="2"/>
-              <a:buChar char="§"/>
-            </a:pPr>
-            <a:r>
-              <a:rPr lang="en-US" sz="2800" dirty="0">
-                <a:latin typeface="+mj-lt"/>
-                <a:cs typeface="Times New Roman" panose="02020603050405020304" pitchFamily="18" charset="0"/>
-              </a:rPr>
-              <a:t>Training a binary classifier</a:t>
-            </a:r>
-          </a:p>
-          <a:p>
-            <a:pPr marL="457200" indent="-457200" algn="l">
-              <a:lnSpc>
-                <a:spcPct val="100000"/>
-              </a:lnSpc>
-              <a:buFont typeface="Wingdings" panose="05000000000000000000" pitchFamily="2" charset="2"/>
-              <a:buChar char="§"/>
-            </a:pPr>
-            <a:r>
-              <a:rPr lang="en-US" sz="2800" dirty="0">
-                <a:latin typeface="+mj-lt"/>
-                <a:cs typeface="Times New Roman" panose="02020603050405020304" pitchFamily="18" charset="0"/>
-              </a:rPr>
-              <a:t>Multiclass (multinomial) classification</a:t>
-            </a:r>
-          </a:p>
-        </p:txBody>
-      </p:sp>
-      <p:sp>
-        <p:nvSpPr>
-          <p:cNvPr id="155" name="Rectangle 143">
-            <a:extLst>
-              <a:ext uri="{FF2B5EF4-FFF2-40B4-BE49-F238E27FC236}">
-                <a16:creationId xmlns:a16="http://schemas.microsoft.com/office/drawing/2014/main" id="{7524B8A9-611C-185B-E9C1-20FB914D23F6}"/>
-              </a:ext>
-            </a:extLst>
-          </p:cNvPr>
-          <p:cNvSpPr>
-            <a:spLocks noChangeArrowheads="1"/>
-          </p:cNvSpPr>
-          <p:nvPr/>
-        </p:nvSpPr>
-        <p:spPr bwMode="auto">
-          <a:xfrm>
-            <a:off x="448342" y="6401243"/>
-            <a:ext cx="5730175" cy="307777"/>
-          </a:xfrm>
-          <a:prstGeom prst="rect">
-            <a:avLst/>
-          </a:prstGeom>
-          <a:noFill/>
-          <a:ln>
-            <a:noFill/>
-          </a:ln>
-          <a:effectLst/>
-          <a:extLst>
-            <a:ext uri="{909E8E84-426E-40DD-AFC4-6F175D3DCCD1}">
-              <a14:hiddenFill xmlns:a14="http://schemas.microsoft.com/office/drawing/2010/main">
-                <a:solidFill>
-                  <a:schemeClr val="accent1"/>
-                </a:solidFill>
-              </a14:hiddenFill>
-            </a:ext>
-            <a:ext uri="{91240B29-F687-4F45-9708-019B960494DF}">
-              <a14:hiddenLine xmlns:a14="http://schemas.microsoft.com/office/drawing/2010/main" w="9525">
-                <a:solidFill>
-                  <a:schemeClr val="tx1"/>
-                </a:solidFill>
-                <a:miter lim="800000"/>
-                <a:headEnd/>
-                <a:tailEnd/>
-              </a14:hiddenLine>
-            </a:ext>
-            <a:ext uri="{AF507438-7753-43E0-B8FC-AC1667EBCBE1}">
-              <a14:hiddenEffects xmlns:a14="http://schemas.microsoft.com/office/drawing/2010/main">
-                <a:effectLst>
-                  <a:outerShdw dist="35921" dir="2700000" algn="ctr" rotWithShape="0">
-                    <a:schemeClr val="bg2"/>
-                  </a:outerShdw>
-                </a:effectLst>
-              </a14:hiddenEffects>
-            </a:ext>
-          </a:extLst>
-        </p:spPr>
-        <p:txBody>
-          <a:bodyPr vert="horz" wrap="square" lIns="91440" tIns="45720" rIns="91440" bIns="45720" numCol="1" anchor="ctr" anchorCtr="0" compatLnSpc="1">
-            <a:prstTxWarp prst="textNoShape">
-              <a:avLst/>
-            </a:prstTxWarp>
-            <a:spAutoFit/>
-          </a:bodyPr>
-          <a:lstStyle/>
-          <a:p>
-            <a:pPr marL="0" marR="0" lvl="0" indent="0" algn="l" defTabSz="914400" rtl="0" eaLnBrk="0" fontAlgn="base" latinLnBrk="0" hangingPunct="0">
-              <a:lnSpc>
-                <a:spcPct val="100000"/>
-              </a:lnSpc>
-              <a:spcBef>
-                <a:spcPct val="0"/>
-              </a:spcBef>
-              <a:spcAft>
-                <a:spcPct val="0"/>
-              </a:spcAft>
-              <a:buClrTx/>
-              <a:buSzTx/>
-              <a:buFontTx/>
-              <a:buNone/>
-              <a:tabLst/>
-            </a:pPr>
-            <a:r>
-              <a:rPr kumimoji="0" lang="en-US" altLang="es-ES" sz="1400" b="0" i="0" u="none" strike="noStrike" cap="none" normalizeH="0" baseline="0" dirty="0">
-                <a:ln>
-                  <a:noFill/>
-                </a:ln>
-                <a:solidFill>
-                  <a:srgbClr val="F4A200"/>
-                </a:solidFill>
-                <a:effectLst/>
-                <a:latin typeface="Arial" panose="020B0604020202020204" pitchFamily="34" charset="0"/>
-                <a:ea typeface="Myriad Pro Light"/>
-                <a:cs typeface="Times New Roman" panose="02020603050405020304" pitchFamily="18" charset="0"/>
-              </a:rPr>
-              <a:t>Master in Quantitative Economic Analysis </a:t>
-            </a:r>
-            <a:r>
-              <a:rPr kumimoji="0" lang="en-US" altLang="es-ES" sz="1400" b="0" i="0" u="none" strike="noStrike" cap="none" normalizeH="0" baseline="0" dirty="0" err="1">
-                <a:ln>
-                  <a:noFill/>
-                </a:ln>
-                <a:solidFill>
-                  <a:srgbClr val="F4A200"/>
-                </a:solidFill>
-                <a:effectLst/>
-                <a:latin typeface="Arial" panose="020B0604020202020204" pitchFamily="34" charset="0"/>
-                <a:ea typeface="Myriad Pro Light"/>
-                <a:cs typeface="Times New Roman" panose="02020603050405020304" pitchFamily="18" charset="0"/>
-              </a:rPr>
-              <a:t>MQuEA</a:t>
-            </a:r>
-            <a:endParaRPr kumimoji="0" lang="es-ES" altLang="es-ES" sz="500" b="0" i="0" u="none" strike="noStrike" cap="none" normalizeH="0" baseline="0" dirty="0">
-              <a:ln>
-                <a:noFill/>
-              </a:ln>
-              <a:solidFill>
-                <a:schemeClr val="tx1"/>
-              </a:solidFill>
-              <a:effectLst/>
-              <a:latin typeface="Arial" panose="020B0604020202020204" pitchFamily="34" charset="0"/>
-            </a:endParaRPr>
-          </a:p>
-        </p:txBody>
-      </p:sp>
-      <p:sp>
-        <p:nvSpPr>
-          <p:cNvPr id="156" name="Rectangle 143">
-            <a:extLst>
-              <a:ext uri="{FF2B5EF4-FFF2-40B4-BE49-F238E27FC236}">
-                <a16:creationId xmlns:a16="http://schemas.microsoft.com/office/drawing/2014/main" id="{8AE2F004-1A39-90D0-AE0D-900815603718}"/>
-              </a:ext>
-            </a:extLst>
-          </p:cNvPr>
-          <p:cNvSpPr>
-            <a:spLocks noChangeArrowheads="1"/>
-          </p:cNvSpPr>
-          <p:nvPr/>
-        </p:nvSpPr>
-        <p:spPr bwMode="auto">
-          <a:xfrm>
-            <a:off x="6186394" y="6411881"/>
-            <a:ext cx="5730175" cy="307777"/>
-          </a:xfrm>
-          <a:prstGeom prst="rect">
-            <a:avLst/>
-          </a:prstGeom>
-          <a:noFill/>
-          <a:ln>
-            <a:noFill/>
-          </a:ln>
-          <a:effectLst/>
-          <a:extLst>
-            <a:ext uri="{909E8E84-426E-40DD-AFC4-6F175D3DCCD1}">
-              <a14:hiddenFill xmlns:a14="http://schemas.microsoft.com/office/drawing/2010/main">
-                <a:solidFill>
-                  <a:schemeClr val="accent1"/>
-                </a:solidFill>
-              </a14:hiddenFill>
-            </a:ext>
-            <a:ext uri="{91240B29-F687-4F45-9708-019B960494DF}">
-              <a14:hiddenLine xmlns:a14="http://schemas.microsoft.com/office/drawing/2010/main" w="9525">
-                <a:solidFill>
-                  <a:schemeClr val="tx1"/>
-                </a:solidFill>
-                <a:miter lim="800000"/>
-                <a:headEnd/>
-                <a:tailEnd/>
-              </a14:hiddenLine>
-            </a:ext>
-            <a:ext uri="{AF507438-7753-43E0-B8FC-AC1667EBCBE1}">
-              <a14:hiddenEffects xmlns:a14="http://schemas.microsoft.com/office/drawing/2010/main">
-                <a:effectLst>
-                  <a:outerShdw dist="35921" dir="2700000" algn="ctr" rotWithShape="0">
-                    <a:schemeClr val="bg2"/>
-                  </a:outerShdw>
-                </a:effectLst>
-              </a14:hiddenEffects>
-            </a:ext>
-          </a:extLst>
-        </p:spPr>
-        <p:txBody>
-          <a:bodyPr vert="horz" wrap="square" lIns="91440" tIns="45720" rIns="91440" bIns="45720" numCol="1" anchor="ctr" anchorCtr="0" compatLnSpc="1">
-            <a:prstTxWarp prst="textNoShape">
-              <a:avLst/>
-            </a:prstTxWarp>
-            <a:spAutoFit/>
-          </a:bodyPr>
-          <a:lstStyle/>
-          <a:p>
-            <a:pPr marL="0" marR="0" lvl="0" indent="0" algn="r" defTabSz="914400" rtl="0" eaLnBrk="0" fontAlgn="base" latinLnBrk="0" hangingPunct="0">
-              <a:lnSpc>
-                <a:spcPct val="100000"/>
-              </a:lnSpc>
-              <a:spcBef>
-                <a:spcPct val="0"/>
-              </a:spcBef>
-              <a:spcAft>
-                <a:spcPct val="0"/>
-              </a:spcAft>
-              <a:buClrTx/>
-              <a:buSzTx/>
-              <a:buFontTx/>
-              <a:buNone/>
-              <a:tabLst/>
-            </a:pPr>
-            <a:r>
-              <a:rPr kumimoji="0" lang="en-US" altLang="es-ES" sz="1400" b="0" i="0" u="none" strike="noStrike" cap="none" normalizeH="0" baseline="0" dirty="0">
-                <a:ln>
-                  <a:noFill/>
-                </a:ln>
-                <a:solidFill>
-                  <a:srgbClr val="F4A200"/>
-                </a:solidFill>
-                <a:effectLst/>
-                <a:latin typeface="Arial" panose="020B0604020202020204" pitchFamily="34" charset="0"/>
-                <a:ea typeface="Myriad Pro Light"/>
-                <a:cs typeface="Times New Roman" panose="02020603050405020304" pitchFamily="18" charset="0"/>
-              </a:rPr>
-              <a:t>Universidad </a:t>
-            </a:r>
-            <a:r>
-              <a:rPr kumimoji="0" lang="en-US" altLang="es-ES" sz="1400" b="0" i="0" u="none" strike="noStrike" cap="none" normalizeH="0" baseline="0" dirty="0" err="1">
-                <a:ln>
-                  <a:noFill/>
-                </a:ln>
-                <a:solidFill>
-                  <a:srgbClr val="F4A200"/>
-                </a:solidFill>
-                <a:effectLst/>
-                <a:latin typeface="Arial" panose="020B0604020202020204" pitchFamily="34" charset="0"/>
-                <a:ea typeface="Myriad Pro Light"/>
-                <a:cs typeface="Times New Roman" panose="02020603050405020304" pitchFamily="18" charset="0"/>
-              </a:rPr>
-              <a:t>Aut</a:t>
-            </a:r>
-            <a:r>
-              <a:rPr lang="en-US" altLang="es-ES" sz="1400" dirty="0" err="1">
-                <a:solidFill>
-                  <a:srgbClr val="F4A200"/>
-                </a:solidFill>
-                <a:latin typeface="Arial" panose="020B0604020202020204" pitchFamily="34" charset="0"/>
-                <a:ea typeface="Myriad Pro Light"/>
-                <a:cs typeface="Times New Roman" panose="02020603050405020304" pitchFamily="18" charset="0"/>
-              </a:rPr>
-              <a:t>ó</a:t>
-            </a:r>
-            <a:r>
-              <a:rPr kumimoji="0" lang="en-US" altLang="es-ES" sz="1400" b="0" i="0" u="none" strike="noStrike" cap="none" normalizeH="0" baseline="0" dirty="0" err="1">
-                <a:ln>
-                  <a:noFill/>
-                </a:ln>
-                <a:solidFill>
-                  <a:srgbClr val="F4A200"/>
-                </a:solidFill>
-                <a:effectLst/>
-                <a:latin typeface="Arial" panose="020B0604020202020204" pitchFamily="34" charset="0"/>
-                <a:ea typeface="Myriad Pro Light"/>
-                <a:cs typeface="Times New Roman" panose="02020603050405020304" pitchFamily="18" charset="0"/>
-              </a:rPr>
-              <a:t>noma</a:t>
-            </a:r>
-            <a:r>
-              <a:rPr kumimoji="0" lang="en-US" altLang="es-ES" sz="1400" b="0" i="0" u="none" strike="noStrike" cap="none" normalizeH="0" baseline="0" dirty="0">
-                <a:ln>
-                  <a:noFill/>
-                </a:ln>
-                <a:solidFill>
-                  <a:srgbClr val="F4A200"/>
-                </a:solidFill>
-                <a:effectLst/>
-                <a:latin typeface="Arial" panose="020B0604020202020204" pitchFamily="34" charset="0"/>
-                <a:ea typeface="Myriad Pro Light"/>
-                <a:cs typeface="Times New Roman" panose="02020603050405020304" pitchFamily="18" charset="0"/>
-              </a:rPr>
-              <a:t> de Madrid</a:t>
-            </a:r>
-            <a:endParaRPr kumimoji="0" lang="es-ES" altLang="es-ES" sz="500" b="0" i="0" u="none" strike="noStrike" cap="none" normalizeH="0" baseline="0" dirty="0">
-              <a:ln>
-                <a:noFill/>
-              </a:ln>
-              <a:solidFill>
-                <a:schemeClr val="tx1"/>
-              </a:solidFill>
-              <a:effectLst/>
-              <a:latin typeface="Arial" panose="020B0604020202020204" pitchFamily="34" charset="0"/>
-            </a:endParaRPr>
-          </a:p>
-        </p:txBody>
-      </p:sp>
-      <p:sp>
-        <p:nvSpPr>
-          <p:cNvPr id="2" name="Title 1">
-            <a:extLst>
-              <a:ext uri="{FF2B5EF4-FFF2-40B4-BE49-F238E27FC236}">
-                <a16:creationId xmlns:a16="http://schemas.microsoft.com/office/drawing/2014/main" id="{6F9A13AB-C9B4-5D9D-DE92-0AD86D5BF818}"/>
-              </a:ext>
-            </a:extLst>
-          </p:cNvPr>
-          <p:cNvSpPr txBox="1">
-            <a:spLocks/>
-          </p:cNvSpPr>
-          <p:nvPr/>
-        </p:nvSpPr>
-        <p:spPr>
-          <a:xfrm>
-            <a:off x="990600" y="517525"/>
-            <a:ext cx="10515600" cy="1325563"/>
-          </a:xfrm>
-          <a:prstGeom prst="rect">
-            <a:avLst/>
-          </a:prstGeom>
-        </p:spPr>
-        <p:txBody>
-          <a:bodyPr vert="horz" lIns="91440" tIns="45720" rIns="91440" bIns="45720" rtlCol="0" anchor="ctr">
-            <a:normAutofit/>
-          </a:bodyPr>
-          <a:lstStyle>
-            <a:lvl1pPr algn="ctr" defTabSz="914400" rtl="0" eaLnBrk="1" latinLnBrk="0" hangingPunct="1">
-              <a:lnSpc>
-                <a:spcPct val="90000"/>
-              </a:lnSpc>
-              <a:spcBef>
-                <a:spcPct val="0"/>
-              </a:spcBef>
-              <a:buNone/>
-              <a:defRPr sz="6000" kern="1200">
-                <a:solidFill>
-                  <a:schemeClr val="tx1"/>
-                </a:solidFill>
-                <a:latin typeface="+mj-lt"/>
-                <a:ea typeface="+mj-ea"/>
-                <a:cs typeface="+mj-cs"/>
-              </a:defRPr>
-            </a:lvl1pPr>
-          </a:lstStyle>
-          <a:p>
-            <a:pPr algn="l"/>
-            <a:r>
-              <a:rPr lang="en-US" sz="4000" dirty="0"/>
-              <a:t>Outline</a:t>
-            </a:r>
-          </a:p>
-        </p:txBody>
-      </p:sp>
-      <p:sp>
-        <p:nvSpPr>
-          <p:cNvPr id="5" name="Arrow: Left 4">
-            <a:extLst>
-              <a:ext uri="{FF2B5EF4-FFF2-40B4-BE49-F238E27FC236}">
-                <a16:creationId xmlns:a16="http://schemas.microsoft.com/office/drawing/2014/main" id="{FD38933F-31C8-2AB5-6517-D9F2A467F431}"/>
-              </a:ext>
-            </a:extLst>
-          </p:cNvPr>
-          <p:cNvSpPr/>
-          <p:nvPr/>
-        </p:nvSpPr>
-        <p:spPr>
-          <a:xfrm rot="20710547">
-            <a:off x="6412261" y="2943630"/>
-            <a:ext cx="1913570" cy="1038099"/>
-          </a:xfrm>
-          <a:prstGeom prst="leftArrow">
-            <a:avLst/>
-          </a:prstGeom>
-          <a:solidFill>
-            <a:srgbClr val="FFFF00"/>
-          </a:solidFill>
-          <a:ln>
-            <a:noFill/>
-          </a:ln>
-        </p:spPr>
-        <p:style>
-          <a:lnRef idx="2">
-            <a:schemeClr val="accent1">
-              <a:shade val="50000"/>
-            </a:schemeClr>
-          </a:lnRef>
-          <a:fillRef idx="1">
-            <a:schemeClr val="accent1"/>
-          </a:fillRef>
-          <a:effectRef idx="0">
-            <a:schemeClr val="accent1"/>
-          </a:effectRef>
-          <a:fontRef idx="minor">
-            <a:schemeClr val="lt1"/>
-          </a:fontRef>
-        </p:style>
-        <p:txBody>
-          <a:bodyPr rtlCol="0" anchor="ctr"/>
-          <a:lstStyle/>
-          <a:p>
-            <a:pPr algn="ctr"/>
-            <a:r>
-              <a:rPr lang="en-US" dirty="0">
-                <a:solidFill>
-                  <a:srgbClr val="FF0000"/>
-                </a:solidFill>
-              </a:rPr>
-              <a:t>This is actually an optimization method!</a:t>
-            </a:r>
-          </a:p>
-        </p:txBody>
-      </p:sp>
-    </p:spTree>
-    <p:extLst>
-      <p:ext uri="{BB962C8B-B14F-4D97-AF65-F5344CB8AC3E}">
-        <p14:creationId xmlns:p14="http://schemas.microsoft.com/office/powerpoint/2010/main" val="3676436470"/>
-      </p:ext>
-    </p:extLst>
-  </p:cSld>
-  <p:clrMapOvr>
-    <a:masterClrMapping/>
-  </p:clrMapOvr>
-</p:sld>
-</file>
-
-<file path=ppt/slides/slide20.xml><?xml version="1.0" encoding="utf-8"?>
+<file path=ppt/slides/slide19.xml><?xml version="1.0" encoding="utf-8"?>
 <p:sld xmlns:a="http://schemas.openxmlformats.org/drawingml/2006/main" xmlns:r="http://schemas.openxmlformats.org/officeDocument/2006/relationships" xmlns:p="http://schemas.openxmlformats.org/presentationml/2006/main">
   <p:cSld>
     <p:spTree>
@@ -30499,7 +29118,7 @@
                   <a:rPr lang="en-US" sz="2000" dirty="0">
                     <a:latin typeface="+mj-lt"/>
                   </a:rPr>
-                  <a:t>Since a harmonic mean gives more weight to low values, the classifier will only get a </a:t>
+                  <a:t>The classifier will only get a </a:t>
                 </a:r>
                 <a:r>
                   <a:rPr lang="en-US" sz="2000" b="1" dirty="0">
@@ -30809,7 +29428,850 @@
 </p:sld>
 </file>
 
-<file path=ppt/slides/slide21.xml><?xml version="1.0" encoding="utf-8"?>
+<file path=ppt/slides/slide2.xml><?xml version="1.0" encoding="utf-8"?>
+<p:sld xmlns:a="http://schemas.openxmlformats.org/drawingml/2006/main" xmlns:r="http://schemas.openxmlformats.org/officeDocument/2006/relationships" xmlns:p="http://schemas.openxmlformats.org/presentationml/2006/main">
+  <p:cSld>
+    <p:spTree>
+      <p:nvGrpSpPr>
+        <p:cNvPr id="1" name=""/>
+        <p:cNvGrpSpPr/>
+        <p:nvPr/>
+      </p:nvGrpSpPr>
+      <p:grpSpPr>
+        <a:xfrm>
+          <a:off x="0" y="0"/>
+          <a:ext cx="0" cy="0"/>
+          <a:chOff x="0" y="0"/>
+          <a:chExt cx="0" cy="0"/>
+        </a:xfrm>
+      </p:grpSpPr>
+      <p:sp>
+        <p:nvSpPr>
+          <p:cNvPr id="4" name="Rectángulo 3">
+            <a:extLst>
+              <a:ext uri="{FF2B5EF4-FFF2-40B4-BE49-F238E27FC236}">
+                <a16:creationId xmlns:a16="http://schemas.microsoft.com/office/drawing/2014/main" id="{DAB19569-A64F-C399-1542-792E0E4616AC}"/>
+              </a:ext>
+            </a:extLst>
+          </p:cNvPr>
+          <p:cNvSpPr/>
+          <p:nvPr/>
+        </p:nvSpPr>
+        <p:spPr>
+          <a:xfrm>
+            <a:off x="0" y="0"/>
+            <a:ext cx="374469" cy="6858000"/>
+          </a:xfrm>
+          <a:prstGeom prst="rect">
+            <a:avLst/>
+          </a:prstGeom>
+        </p:spPr>
+        <p:style>
+          <a:lnRef idx="2">
+            <a:schemeClr val="accent2">
+              <a:shade val="50000"/>
+            </a:schemeClr>
+          </a:lnRef>
+          <a:fillRef idx="1">
+            <a:schemeClr val="accent2"/>
+          </a:fillRef>
+          <a:effectRef idx="0">
+            <a:schemeClr val="accent2"/>
+          </a:effectRef>
+          <a:fontRef idx="minor">
+            <a:schemeClr val="lt1"/>
+          </a:fontRef>
+        </p:style>
+        <p:txBody>
+          <a:bodyPr rtlCol="0" anchor="ctr"/>
+          <a:lstStyle/>
+          <a:p>
+            <a:pPr algn="ctr"/>
+            <a:endParaRPr lang="es-ES"/>
+          </a:p>
+        </p:txBody>
+      </p:sp>
+      <p:sp>
+        <p:nvSpPr>
+          <p:cNvPr id="152" name="Content Placeholder 2">
+            <a:extLst>
+              <a:ext uri="{FF2B5EF4-FFF2-40B4-BE49-F238E27FC236}">
+                <a16:creationId xmlns:a16="http://schemas.microsoft.com/office/drawing/2014/main" id="{B7719AE7-5D76-3CA6-C03E-F772C1896EF4}"/>
+              </a:ext>
+            </a:extLst>
+          </p:cNvPr>
+          <p:cNvSpPr txBox="1">
+            <a:spLocks/>
+          </p:cNvSpPr>
+          <p:nvPr/>
+        </p:nvSpPr>
+        <p:spPr>
+          <a:xfrm>
+            <a:off x="1494790" y="1875615"/>
+            <a:ext cx="9859010" cy="4351338"/>
+          </a:xfrm>
+          <a:prstGeom prst="rect">
+            <a:avLst/>
+          </a:prstGeom>
+        </p:spPr>
+        <p:txBody>
+          <a:bodyPr vert="horz" lIns="91440" tIns="45720" rIns="91440" bIns="45720" rtlCol="0">
+            <a:normAutofit fontScale="92500" lnSpcReduction="10000"/>
+          </a:bodyPr>
+          <a:lstStyle>
+            <a:lvl1pPr marL="0" indent="0" algn="ctr" defTabSz="914400" rtl="0" eaLnBrk="1" latinLnBrk="0" hangingPunct="1">
+              <a:lnSpc>
+                <a:spcPct val="90000"/>
+              </a:lnSpc>
+              <a:spcBef>
+                <a:spcPts val="1000"/>
+              </a:spcBef>
+              <a:buFont typeface="Arial" panose="020B0604020202020204" pitchFamily="34" charset="0"/>
+              <a:buNone/>
+              <a:defRPr sz="2400" kern="1200">
+                <a:solidFill>
+                  <a:schemeClr val="tx1"/>
+                </a:solidFill>
+                <a:latin typeface="+mn-lt"/>
+                <a:ea typeface="+mn-ea"/>
+                <a:cs typeface="+mn-cs"/>
+              </a:defRPr>
+            </a:lvl1pPr>
+            <a:lvl2pPr marL="457200" indent="0" algn="ctr" defTabSz="914400" rtl="0" eaLnBrk="1" latinLnBrk="0" hangingPunct="1">
+              <a:lnSpc>
+                <a:spcPct val="90000"/>
+              </a:lnSpc>
+              <a:spcBef>
+                <a:spcPts val="500"/>
+              </a:spcBef>
+              <a:buFont typeface="Arial" panose="020B0604020202020204" pitchFamily="34" charset="0"/>
+              <a:buNone/>
+              <a:defRPr sz="2000" kern="1200">
+                <a:solidFill>
+                  <a:schemeClr val="tx1"/>
+                </a:solidFill>
+                <a:latin typeface="+mn-lt"/>
+                <a:ea typeface="+mn-ea"/>
+                <a:cs typeface="+mn-cs"/>
+              </a:defRPr>
+            </a:lvl2pPr>
+            <a:lvl3pPr marL="914400" indent="0" algn="ctr" defTabSz="914400" rtl="0" eaLnBrk="1" latinLnBrk="0" hangingPunct="1">
+              <a:lnSpc>
+                <a:spcPct val="90000"/>
+              </a:lnSpc>
+              <a:spcBef>
+                <a:spcPts val="500"/>
+              </a:spcBef>
+              <a:buFont typeface="Arial" panose="020B0604020202020204" pitchFamily="34" charset="0"/>
+              <a:buNone/>
+              <a:defRPr sz="1800" kern="1200">
+                <a:solidFill>
+                  <a:schemeClr val="tx1"/>
+                </a:solidFill>
+                <a:latin typeface="+mn-lt"/>
+                <a:ea typeface="+mn-ea"/>
+                <a:cs typeface="+mn-cs"/>
+              </a:defRPr>
+            </a:lvl3pPr>
+            <a:lvl4pPr marL="1371600" indent="0" algn="ctr" defTabSz="914400" rtl="0" eaLnBrk="1" latinLnBrk="0" hangingPunct="1">
+              <a:lnSpc>
+                <a:spcPct val="90000"/>
+              </a:lnSpc>
+              <a:spcBef>
+                <a:spcPts val="500"/>
+              </a:spcBef>
+              <a:buFont typeface="Arial" panose="020B0604020202020204" pitchFamily="34" charset="0"/>
+              <a:buNone/>
+              <a:defRPr sz="1600" kern="1200">
+                <a:solidFill>
+                  <a:schemeClr val="tx1"/>
+                </a:solidFill>
+                <a:latin typeface="+mn-lt"/>
+                <a:ea typeface="+mn-ea"/>
+                <a:cs typeface="+mn-cs"/>
+              </a:defRPr>
+            </a:lvl4pPr>
+            <a:lvl5pPr marL="1828800" indent="0" algn="ctr" defTabSz="914400" rtl="0" eaLnBrk="1" latinLnBrk="0" hangingPunct="1">
+              <a:lnSpc>
+                <a:spcPct val="90000"/>
+              </a:lnSpc>
+              <a:spcBef>
+                <a:spcPts val="500"/>
+              </a:spcBef>
+              <a:buFont typeface="Arial" panose="020B0604020202020204" pitchFamily="34" charset="0"/>
+              <a:buNone/>
+              <a:defRPr sz="1600" kern="1200">
+                <a:solidFill>
+                  <a:schemeClr val="tx1"/>
+                </a:solidFill>
+                <a:latin typeface="+mn-lt"/>
+                <a:ea typeface="+mn-ea"/>
+                <a:cs typeface="+mn-cs"/>
+              </a:defRPr>
+            </a:lvl5pPr>
+            <a:lvl6pPr marL="2286000" indent="0" algn="ctr" defTabSz="914400" rtl="0" eaLnBrk="1" latinLnBrk="0" hangingPunct="1">
+              <a:lnSpc>
+                <a:spcPct val="90000"/>
+              </a:lnSpc>
+              <a:spcBef>
+                <a:spcPts val="500"/>
+              </a:spcBef>
+              <a:buFont typeface="Arial" panose="020B0604020202020204" pitchFamily="34" charset="0"/>
+              <a:buNone/>
+              <a:defRPr sz="1600" kern="1200">
+                <a:solidFill>
+                  <a:schemeClr val="tx1"/>
+                </a:solidFill>
+                <a:latin typeface="+mn-lt"/>
+                <a:ea typeface="+mn-ea"/>
+                <a:cs typeface="+mn-cs"/>
+              </a:defRPr>
+            </a:lvl6pPr>
+            <a:lvl7pPr marL="2743200" indent="0" algn="ctr" defTabSz="914400" rtl="0" eaLnBrk="1" latinLnBrk="0" hangingPunct="1">
+              <a:lnSpc>
+                <a:spcPct val="90000"/>
+              </a:lnSpc>
+              <a:spcBef>
+                <a:spcPts val="500"/>
+              </a:spcBef>
+              <a:buFont typeface="Arial" panose="020B0604020202020204" pitchFamily="34" charset="0"/>
+              <a:buNone/>
+              <a:defRPr sz="1600" kern="1200">
+                <a:solidFill>
+                  <a:schemeClr val="tx1"/>
+                </a:solidFill>
+                <a:latin typeface="+mn-lt"/>
+                <a:ea typeface="+mn-ea"/>
+                <a:cs typeface="+mn-cs"/>
+              </a:defRPr>
+            </a:lvl7pPr>
+            <a:lvl8pPr marL="3200400" indent="0" algn="ctr" defTabSz="914400" rtl="0" eaLnBrk="1" latinLnBrk="0" hangingPunct="1">
+              <a:lnSpc>
+                <a:spcPct val="90000"/>
+              </a:lnSpc>
+              <a:spcBef>
+                <a:spcPts val="500"/>
+              </a:spcBef>
+              <a:buFont typeface="Arial" panose="020B0604020202020204" pitchFamily="34" charset="0"/>
+              <a:buNone/>
+              <a:defRPr sz="1600" kern="1200">
+                <a:solidFill>
+                  <a:schemeClr val="tx1"/>
+                </a:solidFill>
+                <a:latin typeface="+mn-lt"/>
+                <a:ea typeface="+mn-ea"/>
+                <a:cs typeface="+mn-cs"/>
+              </a:defRPr>
+            </a:lvl8pPr>
+            <a:lvl9pPr marL="3657600" indent="0" algn="ctr" defTabSz="914400" rtl="0" eaLnBrk="1" latinLnBrk="0" hangingPunct="1">
+              <a:lnSpc>
+                <a:spcPct val="90000"/>
+              </a:lnSpc>
+              <a:spcBef>
+                <a:spcPts val="500"/>
+              </a:spcBef>
+              <a:buFont typeface="Arial" panose="020B0604020202020204" pitchFamily="34" charset="0"/>
+              <a:buNone/>
+              <a:defRPr sz="1600" kern="1200">
+                <a:solidFill>
+                  <a:schemeClr val="tx1"/>
+                </a:solidFill>
+                <a:latin typeface="+mn-lt"/>
+                <a:ea typeface="+mn-ea"/>
+                <a:cs typeface="+mn-cs"/>
+              </a:defRPr>
+            </a:lvl9pPr>
+          </a:lstStyle>
+          <a:p>
+            <a:pPr marL="457200" indent="-457200" algn="l">
+              <a:lnSpc>
+                <a:spcPct val="100000"/>
+              </a:lnSpc>
+              <a:buFont typeface="Wingdings" panose="05000000000000000000" pitchFamily="2" charset="2"/>
+              <a:buChar char="§"/>
+            </a:pPr>
+            <a:r>
+              <a:rPr lang="en-US" sz="2800" dirty="0">
+                <a:latin typeface="+mj-lt"/>
+                <a:cs typeface="Times New Roman" panose="02020603050405020304" pitchFamily="18" charset="0"/>
+              </a:rPr>
+              <a:t>Classifying?</a:t>
+            </a:r>
+          </a:p>
+          <a:p>
+            <a:pPr marL="457200" indent="-457200" algn="l">
+              <a:lnSpc>
+                <a:spcPct val="100000"/>
+              </a:lnSpc>
+              <a:buFont typeface="Wingdings" panose="05000000000000000000" pitchFamily="2" charset="2"/>
+              <a:buChar char="§"/>
+            </a:pPr>
+            <a:r>
+              <a:rPr lang="en-US" sz="2800" dirty="0">
+                <a:latin typeface="+mj-lt"/>
+                <a:cs typeface="Times New Roman" panose="02020603050405020304" pitchFamily="18" charset="0"/>
+              </a:rPr>
+              <a:t>Classifiers</a:t>
+            </a:r>
+          </a:p>
+          <a:p>
+            <a:pPr marL="914400" lvl="1" indent="-457200" algn="l">
+              <a:lnSpc>
+                <a:spcPct val="100000"/>
+              </a:lnSpc>
+              <a:buFont typeface="Wingdings" panose="05000000000000000000" pitchFamily="2" charset="2"/>
+              <a:buChar char="§"/>
+            </a:pPr>
+            <a:r>
+              <a:rPr lang="en-US" sz="2400" dirty="0">
+                <a:latin typeface="+mj-lt"/>
+                <a:cs typeface="Times New Roman" panose="02020603050405020304" pitchFamily="18" charset="0"/>
+              </a:rPr>
+              <a:t>Logistic Regression</a:t>
+            </a:r>
+          </a:p>
+          <a:p>
+            <a:pPr marL="914400" lvl="1" indent="-457200" algn="l">
+              <a:lnSpc>
+                <a:spcPct val="100000"/>
+              </a:lnSpc>
+              <a:buFont typeface="Wingdings" panose="05000000000000000000" pitchFamily="2" charset="2"/>
+              <a:buChar char="§"/>
+            </a:pPr>
+            <a:r>
+              <a:rPr lang="en-US" sz="2400" dirty="0">
+                <a:latin typeface="+mj-lt"/>
+                <a:cs typeface="Times New Roman" panose="02020603050405020304" pitchFamily="18" charset="0"/>
+              </a:rPr>
+              <a:t>Linear discriminant analysis (LDA)</a:t>
+            </a:r>
+          </a:p>
+          <a:p>
+            <a:pPr marL="914400" lvl="1" indent="-457200" algn="l">
+              <a:lnSpc>
+                <a:spcPct val="100000"/>
+              </a:lnSpc>
+              <a:buFont typeface="Wingdings" panose="05000000000000000000" pitchFamily="2" charset="2"/>
+              <a:buChar char="§"/>
+            </a:pPr>
+            <a:r>
+              <a:rPr lang="en-US" sz="2400" dirty="0">
+                <a:latin typeface="+mj-lt"/>
+                <a:cs typeface="Times New Roman" panose="02020603050405020304" pitchFamily="18" charset="0"/>
+              </a:rPr>
+              <a:t>Stochastic Gradient Descent (SGD)</a:t>
+            </a:r>
+          </a:p>
+          <a:p>
+            <a:pPr marL="914400" lvl="1" indent="-457200" algn="l">
+              <a:lnSpc>
+                <a:spcPct val="100000"/>
+              </a:lnSpc>
+              <a:buFont typeface="Wingdings" panose="05000000000000000000" pitchFamily="2" charset="2"/>
+              <a:buChar char="§"/>
+            </a:pPr>
+            <a:r>
+              <a:rPr lang="en-US" sz="2400" dirty="0">
+                <a:latin typeface="+mj-lt"/>
+                <a:cs typeface="Times New Roman" panose="02020603050405020304" pitchFamily="18" charset="0"/>
+              </a:rPr>
+              <a:t>Support Vector Machines (SVM)</a:t>
+            </a:r>
+          </a:p>
+          <a:p>
+            <a:pPr marL="914400" lvl="1" indent="-457200" algn="l">
+              <a:lnSpc>
+                <a:spcPct val="100000"/>
+              </a:lnSpc>
+              <a:buFont typeface="Wingdings" panose="05000000000000000000" pitchFamily="2" charset="2"/>
+              <a:buChar char="§"/>
+            </a:pPr>
+            <a:r>
+              <a:rPr lang="en-US" sz="2400" i="1" dirty="0">
+                <a:latin typeface="+mj-lt"/>
+                <a:cs typeface="Times New Roman" panose="02020603050405020304" pitchFamily="18" charset="0"/>
+              </a:rPr>
+              <a:t>K</a:t>
+            </a:r>
+            <a:r>
+              <a:rPr lang="en-US" sz="2400" dirty="0">
+                <a:latin typeface="+mj-lt"/>
+                <a:cs typeface="Times New Roman" panose="02020603050405020304" pitchFamily="18" charset="0"/>
+              </a:rPr>
+              <a:t>-Nearest Neighbors (KNN)</a:t>
+            </a:r>
+            <a:endParaRPr lang="en-US" sz="2400" i="1" dirty="0">
+              <a:latin typeface="+mj-lt"/>
+              <a:cs typeface="Times New Roman" panose="02020603050405020304" pitchFamily="18" charset="0"/>
+            </a:endParaRPr>
+          </a:p>
+          <a:p>
+            <a:pPr marL="457200" indent="-457200" algn="l">
+              <a:lnSpc>
+                <a:spcPct val="100000"/>
+              </a:lnSpc>
+              <a:buFont typeface="Wingdings" panose="05000000000000000000" pitchFamily="2" charset="2"/>
+              <a:buChar char="§"/>
+            </a:pPr>
+            <a:r>
+              <a:rPr lang="en-US" sz="2800" dirty="0">
+                <a:latin typeface="+mj-lt"/>
+                <a:cs typeface="Times New Roman" panose="02020603050405020304" pitchFamily="18" charset="0"/>
+              </a:rPr>
+              <a:t>Performance measures</a:t>
+            </a:r>
+          </a:p>
+          <a:p>
+            <a:pPr marL="457200" indent="-457200" algn="l">
+              <a:lnSpc>
+                <a:spcPct val="100000"/>
+              </a:lnSpc>
+              <a:buFont typeface="Wingdings" panose="05000000000000000000" pitchFamily="2" charset="2"/>
+              <a:buChar char="§"/>
+            </a:pPr>
+            <a:r>
+              <a:rPr lang="en-US" sz="2800" dirty="0">
+                <a:latin typeface="+mj-lt"/>
+                <a:cs typeface="Times New Roman" panose="02020603050405020304" pitchFamily="18" charset="0"/>
+              </a:rPr>
+              <a:t>Training a binary classifier</a:t>
+            </a:r>
+          </a:p>
+          <a:p>
+            <a:pPr marL="457200" indent="-457200" algn="l">
+              <a:lnSpc>
+                <a:spcPct val="100000"/>
+              </a:lnSpc>
+              <a:buFont typeface="Wingdings" panose="05000000000000000000" pitchFamily="2" charset="2"/>
+              <a:buChar char="§"/>
+            </a:pPr>
+            <a:r>
+              <a:rPr lang="en-US" sz="2800" dirty="0">
+                <a:latin typeface="+mj-lt"/>
+                <a:cs typeface="Times New Roman" panose="02020603050405020304" pitchFamily="18" charset="0"/>
+              </a:rPr>
+              <a:t>Multiclass (multinomial) classification</a:t>
+            </a:r>
+          </a:p>
+        </p:txBody>
+      </p:sp>
+      <p:sp>
+        <p:nvSpPr>
+          <p:cNvPr id="155" name="Rectangle 143">
+            <a:extLst>
+              <a:ext uri="{FF2B5EF4-FFF2-40B4-BE49-F238E27FC236}">
+                <a16:creationId xmlns:a16="http://schemas.microsoft.com/office/drawing/2014/main" id="{7524B8A9-611C-185B-E9C1-20FB914D23F6}"/>
+              </a:ext>
+            </a:extLst>
+          </p:cNvPr>
+          <p:cNvSpPr>
+            <a:spLocks noChangeArrowheads="1"/>
+          </p:cNvSpPr>
+          <p:nvPr/>
+        </p:nvSpPr>
+        <p:spPr bwMode="auto">
+          <a:xfrm>
+            <a:off x="448342" y="6401243"/>
+            <a:ext cx="5730175" cy="307777"/>
+          </a:xfrm>
+          <a:prstGeom prst="rect">
+            <a:avLst/>
+          </a:prstGeom>
+          <a:noFill/>
+          <a:ln>
+            <a:noFill/>
+          </a:ln>
+          <a:effectLst/>
+          <a:extLst>
+            <a:ext uri="{909E8E84-426E-40DD-AFC4-6F175D3DCCD1}">
+              <a14:hiddenFill xmlns:a14="http://schemas.microsoft.com/office/drawing/2010/main">
+                <a:solidFill>
+                  <a:schemeClr val="accent1"/>
+                </a:solidFill>
+              </a14:hiddenFill>
+            </a:ext>
+            <a:ext uri="{91240B29-F687-4F45-9708-019B960494DF}">
+              <a14:hiddenLine xmlns:a14="http://schemas.microsoft.com/office/drawing/2010/main" w="9525">
+                <a:solidFill>
+                  <a:schemeClr val="tx1"/>
+                </a:solidFill>
+                <a:miter lim="800000"/>
+                <a:headEnd/>
+                <a:tailEnd/>
+              </a14:hiddenLine>
+            </a:ext>
+            <a:ext uri="{AF507438-7753-43E0-B8FC-AC1667EBCBE1}">
+              <a14:hiddenEffects xmlns:a14="http://schemas.microsoft.com/office/drawing/2010/main">
+                <a:effectLst>
+                  <a:outerShdw dist="35921" dir="2700000" algn="ctr" rotWithShape="0">
+                    <a:schemeClr val="bg2"/>
+                  </a:outerShdw>
+                </a:effectLst>
+              </a14:hiddenEffects>
+            </a:ext>
+          </a:extLst>
+        </p:spPr>
+        <p:txBody>
+          <a:bodyPr vert="horz" wrap="square" lIns="91440" tIns="45720" rIns="91440" bIns="45720" numCol="1" anchor="ctr" anchorCtr="0" compatLnSpc="1">
+            <a:prstTxWarp prst="textNoShape">
+              <a:avLst/>
+            </a:prstTxWarp>
+            <a:spAutoFit/>
+          </a:bodyPr>
+          <a:lstStyle/>
+          <a:p>
+            <a:pPr marL="0" marR="0" lvl="0" indent="0" algn="l" defTabSz="914400" rtl="0" eaLnBrk="0" fontAlgn="base" latinLnBrk="0" hangingPunct="0">
+              <a:lnSpc>
+                <a:spcPct val="100000"/>
+              </a:lnSpc>
+              <a:spcBef>
+                <a:spcPct val="0"/>
+              </a:spcBef>
+              <a:spcAft>
+                <a:spcPct val="0"/>
+              </a:spcAft>
+              <a:buClrTx/>
+              <a:buSzTx/>
+              <a:buFontTx/>
+              <a:buNone/>
+              <a:tabLst/>
+            </a:pPr>
+            <a:r>
+              <a:rPr kumimoji="0" lang="en-US" altLang="es-ES" sz="1400" b="0" i="0" u="none" strike="noStrike" cap="none" normalizeH="0" baseline="0" dirty="0">
+                <a:ln>
+                  <a:noFill/>
+                </a:ln>
+                <a:solidFill>
+                  <a:srgbClr val="F4A200"/>
+                </a:solidFill>
+                <a:effectLst/>
+                <a:latin typeface="Arial" panose="020B0604020202020204" pitchFamily="34" charset="0"/>
+                <a:ea typeface="Myriad Pro Light"/>
+                <a:cs typeface="Times New Roman" panose="02020603050405020304" pitchFamily="18" charset="0"/>
+              </a:rPr>
+              <a:t>Master in Quantitative Economic Analysis </a:t>
+            </a:r>
+            <a:r>
+              <a:rPr kumimoji="0" lang="en-US" altLang="es-ES" sz="1400" b="0" i="0" u="none" strike="noStrike" cap="none" normalizeH="0" baseline="0" dirty="0" err="1">
+                <a:ln>
+                  <a:noFill/>
+                </a:ln>
+                <a:solidFill>
+                  <a:srgbClr val="F4A200"/>
+                </a:solidFill>
+                <a:effectLst/>
+                <a:latin typeface="Arial" panose="020B0604020202020204" pitchFamily="34" charset="0"/>
+                <a:ea typeface="Myriad Pro Light"/>
+                <a:cs typeface="Times New Roman" panose="02020603050405020304" pitchFamily="18" charset="0"/>
+              </a:rPr>
+              <a:t>MQuEA</a:t>
+            </a:r>
+            <a:endParaRPr kumimoji="0" lang="es-ES" altLang="es-ES" sz="500" b="0" i="0" u="none" strike="noStrike" cap="none" normalizeH="0" baseline="0" dirty="0">
+              <a:ln>
+                <a:noFill/>
+              </a:ln>
+              <a:solidFill>
+                <a:schemeClr val="tx1"/>
+              </a:solidFill>
+              <a:effectLst/>
+              <a:latin typeface="Arial" panose="020B0604020202020204" pitchFamily="34" charset="0"/>
+            </a:endParaRPr>
+          </a:p>
+        </p:txBody>
+      </p:sp>
+      <p:sp>
+        <p:nvSpPr>
+          <p:cNvPr id="156" name="Rectangle 143">
+            <a:extLst>
+              <a:ext uri="{FF2B5EF4-FFF2-40B4-BE49-F238E27FC236}">
+                <a16:creationId xmlns:a16="http://schemas.microsoft.com/office/drawing/2014/main" id="{8AE2F004-1A39-90D0-AE0D-900815603718}"/>
+              </a:ext>
+            </a:extLst>
+          </p:cNvPr>
+          <p:cNvSpPr>
+            <a:spLocks noChangeArrowheads="1"/>
+          </p:cNvSpPr>
+          <p:nvPr/>
+        </p:nvSpPr>
+        <p:spPr bwMode="auto">
+          <a:xfrm>
+            <a:off x="6186394" y="6411881"/>
+            <a:ext cx="5730175" cy="307777"/>
+          </a:xfrm>
+          <a:prstGeom prst="rect">
+            <a:avLst/>
+          </a:prstGeom>
+          <a:noFill/>
+          <a:ln>
+            <a:noFill/>
+          </a:ln>
+          <a:effectLst/>
+          <a:extLst>
+            <a:ext uri="{909E8E84-426E-40DD-AFC4-6F175D3DCCD1}">
+              <a14:hiddenFill xmlns:a14="http://schemas.microsoft.com/office/drawing/2010/main">
+                <a:solidFill>
+                  <a:schemeClr val="accent1"/>
+                </a:solidFill>
+              </a14:hiddenFill>
+            </a:ext>
+            <a:ext uri="{91240B29-F687-4F45-9708-019B960494DF}">
+              <a14:hiddenLine xmlns:a14="http://schemas.microsoft.com/office/drawing/2010/main" w="9525">
+                <a:solidFill>
+                  <a:schemeClr val="tx1"/>
+                </a:solidFill>
+                <a:miter lim="800000"/>
+                <a:headEnd/>
+                <a:tailEnd/>
+              </a14:hiddenLine>
+            </a:ext>
+            <a:ext uri="{AF507438-7753-43E0-B8FC-AC1667EBCBE1}">
+              <a14:hiddenEffects xmlns:a14="http://schemas.microsoft.com/office/drawing/2010/main">
+                <a:effectLst>
+                  <a:outerShdw dist="35921" dir="2700000" algn="ctr" rotWithShape="0">
+                    <a:schemeClr val="bg2"/>
+                  </a:outerShdw>
+                </a:effectLst>
+              </a14:hiddenEffects>
+            </a:ext>
+          </a:extLst>
+        </p:spPr>
+        <p:txBody>
+          <a:bodyPr vert="horz" wrap="square" lIns="91440" tIns="45720" rIns="91440" bIns="45720" numCol="1" anchor="ctr" anchorCtr="0" compatLnSpc="1">
+            <a:prstTxWarp prst="textNoShape">
+              <a:avLst/>
+            </a:prstTxWarp>
+            <a:spAutoFit/>
+          </a:bodyPr>
+          <a:lstStyle/>
+          <a:p>
+            <a:pPr marL="0" marR="0" lvl="0" indent="0" algn="r" defTabSz="914400" rtl="0" eaLnBrk="0" fontAlgn="base" latinLnBrk="0" hangingPunct="0">
+              <a:lnSpc>
+                <a:spcPct val="100000"/>
+              </a:lnSpc>
+              <a:spcBef>
+                <a:spcPct val="0"/>
+              </a:spcBef>
+              <a:spcAft>
+                <a:spcPct val="0"/>
+              </a:spcAft>
+              <a:buClrTx/>
+              <a:buSzTx/>
+              <a:buFontTx/>
+              <a:buNone/>
+              <a:tabLst/>
+            </a:pPr>
+            <a:r>
+              <a:rPr kumimoji="0" lang="en-US" altLang="es-ES" sz="1400" b="0" i="0" u="none" strike="noStrike" cap="none" normalizeH="0" baseline="0" dirty="0">
+                <a:ln>
+                  <a:noFill/>
+                </a:ln>
+                <a:solidFill>
+                  <a:srgbClr val="F4A200"/>
+                </a:solidFill>
+                <a:effectLst/>
+                <a:latin typeface="Arial" panose="020B0604020202020204" pitchFamily="34" charset="0"/>
+                <a:ea typeface="Myriad Pro Light"/>
+                <a:cs typeface="Times New Roman" panose="02020603050405020304" pitchFamily="18" charset="0"/>
+              </a:rPr>
+              <a:t>Universidad </a:t>
+            </a:r>
+            <a:r>
+              <a:rPr kumimoji="0" lang="en-US" altLang="es-ES" sz="1400" b="0" i="0" u="none" strike="noStrike" cap="none" normalizeH="0" baseline="0" dirty="0" err="1">
+                <a:ln>
+                  <a:noFill/>
+                </a:ln>
+                <a:solidFill>
+                  <a:srgbClr val="F4A200"/>
+                </a:solidFill>
+                <a:effectLst/>
+                <a:latin typeface="Arial" panose="020B0604020202020204" pitchFamily="34" charset="0"/>
+                <a:ea typeface="Myriad Pro Light"/>
+                <a:cs typeface="Times New Roman" panose="02020603050405020304" pitchFamily="18" charset="0"/>
+              </a:rPr>
+              <a:t>Aut</a:t>
+            </a:r>
+            <a:r>
+              <a:rPr lang="en-US" altLang="es-ES" sz="1400" dirty="0" err="1">
+                <a:solidFill>
+                  <a:srgbClr val="F4A200"/>
+                </a:solidFill>
+                <a:latin typeface="Arial" panose="020B0604020202020204" pitchFamily="34" charset="0"/>
+                <a:ea typeface="Myriad Pro Light"/>
+                <a:cs typeface="Times New Roman" panose="02020603050405020304" pitchFamily="18" charset="0"/>
+              </a:rPr>
+              <a:t>ó</a:t>
+            </a:r>
+            <a:r>
+              <a:rPr kumimoji="0" lang="en-US" altLang="es-ES" sz="1400" b="0" i="0" u="none" strike="noStrike" cap="none" normalizeH="0" baseline="0" dirty="0" err="1">
+                <a:ln>
+                  <a:noFill/>
+                </a:ln>
+                <a:solidFill>
+                  <a:srgbClr val="F4A200"/>
+                </a:solidFill>
+                <a:effectLst/>
+                <a:latin typeface="Arial" panose="020B0604020202020204" pitchFamily="34" charset="0"/>
+                <a:ea typeface="Myriad Pro Light"/>
+                <a:cs typeface="Times New Roman" panose="02020603050405020304" pitchFamily="18" charset="0"/>
+              </a:rPr>
+              <a:t>noma</a:t>
+            </a:r>
+            <a:r>
+              <a:rPr kumimoji="0" lang="en-US" altLang="es-ES" sz="1400" b="0" i="0" u="none" strike="noStrike" cap="none" normalizeH="0" baseline="0" dirty="0">
+                <a:ln>
+                  <a:noFill/>
+                </a:ln>
+                <a:solidFill>
+                  <a:srgbClr val="F4A200"/>
+                </a:solidFill>
+                <a:effectLst/>
+                <a:latin typeface="Arial" panose="020B0604020202020204" pitchFamily="34" charset="0"/>
+                <a:ea typeface="Myriad Pro Light"/>
+                <a:cs typeface="Times New Roman" panose="02020603050405020304" pitchFamily="18" charset="0"/>
+              </a:rPr>
+              <a:t> de Madrid</a:t>
+            </a:r>
+            <a:endParaRPr kumimoji="0" lang="es-ES" altLang="es-ES" sz="500" b="0" i="0" u="none" strike="noStrike" cap="none" normalizeH="0" baseline="0" dirty="0">
+              <a:ln>
+                <a:noFill/>
+              </a:ln>
+              <a:solidFill>
+                <a:schemeClr val="tx1"/>
+              </a:solidFill>
+              <a:effectLst/>
+              <a:latin typeface="Arial" panose="020B0604020202020204" pitchFamily="34" charset="0"/>
+            </a:endParaRPr>
+          </a:p>
+        </p:txBody>
+      </p:sp>
+      <p:sp>
+        <p:nvSpPr>
+          <p:cNvPr id="2" name="Title 1">
+            <a:extLst>
+              <a:ext uri="{FF2B5EF4-FFF2-40B4-BE49-F238E27FC236}">
+                <a16:creationId xmlns:a16="http://schemas.microsoft.com/office/drawing/2014/main" id="{6F9A13AB-C9B4-5D9D-DE92-0AD86D5BF818}"/>
+              </a:ext>
+            </a:extLst>
+          </p:cNvPr>
+          <p:cNvSpPr txBox="1">
+            <a:spLocks/>
+          </p:cNvSpPr>
+          <p:nvPr/>
+        </p:nvSpPr>
+        <p:spPr>
+          <a:xfrm>
+            <a:off x="990600" y="517525"/>
+            <a:ext cx="10515600" cy="1325563"/>
+          </a:xfrm>
+          <a:prstGeom prst="rect">
+            <a:avLst/>
+          </a:prstGeom>
+        </p:spPr>
+        <p:txBody>
+          <a:bodyPr vert="horz" lIns="91440" tIns="45720" rIns="91440" bIns="45720" rtlCol="0" anchor="ctr">
+            <a:normAutofit/>
+          </a:bodyPr>
+          <a:lstStyle>
+            <a:lvl1pPr algn="ctr" defTabSz="914400" rtl="0" eaLnBrk="1" latinLnBrk="0" hangingPunct="1">
+              <a:lnSpc>
+                <a:spcPct val="90000"/>
+              </a:lnSpc>
+              <a:spcBef>
+                <a:spcPct val="0"/>
+              </a:spcBef>
+              <a:buNone/>
+              <a:defRPr sz="6000" kern="1200">
+                <a:solidFill>
+                  <a:schemeClr val="tx1"/>
+                </a:solidFill>
+                <a:latin typeface="+mj-lt"/>
+                <a:ea typeface="+mj-ea"/>
+                <a:cs typeface="+mj-cs"/>
+              </a:defRPr>
+            </a:lvl1pPr>
+          </a:lstStyle>
+          <a:p>
+            <a:pPr algn="l"/>
+            <a:r>
+              <a:rPr lang="en-US" sz="4000" dirty="0"/>
+              <a:t>Outline</a:t>
+            </a:r>
+          </a:p>
+        </p:txBody>
+      </p:sp>
+      <p:sp>
+        <p:nvSpPr>
+          <p:cNvPr id="5" name="Arrow: Left 4">
+            <a:extLst>
+              <a:ext uri="{FF2B5EF4-FFF2-40B4-BE49-F238E27FC236}">
+                <a16:creationId xmlns:a16="http://schemas.microsoft.com/office/drawing/2014/main" id="{FD38933F-31C8-2AB5-6517-D9F2A467F431}"/>
+              </a:ext>
+            </a:extLst>
+          </p:cNvPr>
+          <p:cNvSpPr/>
+          <p:nvPr/>
+        </p:nvSpPr>
+        <p:spPr>
+          <a:xfrm rot="20710547">
+            <a:off x="6412261" y="2943630"/>
+            <a:ext cx="1913570" cy="1038099"/>
+          </a:xfrm>
+          <a:prstGeom prst="leftArrow">
+            <a:avLst/>
+          </a:prstGeom>
+          <a:solidFill>
+            <a:srgbClr val="FFFF00"/>
+          </a:solidFill>
+          <a:ln>
+            <a:noFill/>
+          </a:ln>
+        </p:spPr>
+        <p:style>
+          <a:lnRef idx="2">
+            <a:schemeClr val="accent1">
+              <a:shade val="50000"/>
+            </a:schemeClr>
+          </a:lnRef>
+          <a:fillRef idx="1">
+            <a:schemeClr val="accent1"/>
+          </a:fillRef>
+          <a:effectRef idx="0">
+            <a:schemeClr val="accent1"/>
+          </a:effectRef>
+          <a:fontRef idx="minor">
+            <a:schemeClr val="lt1"/>
+          </a:fontRef>
+        </p:style>
+        <p:txBody>
+          <a:bodyPr rtlCol="0" anchor="ctr"/>
+          <a:lstStyle/>
+          <a:p>
+            <a:pPr algn="ctr"/>
+            <a:r>
+              <a:rPr lang="en-US" dirty="0">
+                <a:solidFill>
+                  <a:srgbClr val="FF0000"/>
+                </a:solidFill>
+              </a:rPr>
+              <a:t>This is actually an optimization method!</a:t>
+            </a:r>
+          </a:p>
+        </p:txBody>
+      </p:sp>
+    </p:spTree>
+    <p:extLst>
+      <p:ext uri="{BB962C8B-B14F-4D97-AF65-F5344CB8AC3E}">
+        <p14:creationId xmlns:p14="http://schemas.microsoft.com/office/powerpoint/2010/main" val="3676436470"/>
+      </p:ext>
+    </p:extLst>
+  </p:cSld>
+  <p:clrMapOvr>
+    <a:masterClrMapping/>
+  </p:clrMapOvr>
+</p:sld>
+</file>
+
+<file path=ppt/slides/slide20.xml><?xml version="1.0" encoding="utf-8"?>
 <p:sld xmlns:a="http://schemas.openxmlformats.org/drawingml/2006/main" xmlns:r="http://schemas.openxmlformats.org/officeDocument/2006/relationships" xmlns:p="http://schemas.openxmlformats.org/presentationml/2006/main">
   <p:cSld>
     <p:spTree>
@@ -31281,6 +30743,291 @@
           </a:prstGeom>
         </p:spPr>
       </p:pic>
+      <p:sp>
+        <p:nvSpPr>
+          <p:cNvPr id="7" name="TextBox 6">
+            <a:extLst>
+              <a:ext uri="{FF2B5EF4-FFF2-40B4-BE49-F238E27FC236}">
+                <a16:creationId xmlns:a16="http://schemas.microsoft.com/office/drawing/2014/main" id="{37720FBC-73EA-B6D0-4103-EA431CC846B4}"/>
+              </a:ext>
+            </a:extLst>
+          </p:cNvPr>
+          <p:cNvSpPr txBox="1"/>
+          <p:nvPr/>
+        </p:nvSpPr>
+        <p:spPr>
+          <a:xfrm>
+            <a:off x="9227382" y="3710710"/>
+            <a:ext cx="2493989" cy="738664"/>
+          </a:xfrm>
+          <a:prstGeom prst="rect">
+            <a:avLst/>
+          </a:prstGeom>
+          <a:noFill/>
+        </p:spPr>
+        <p:txBody>
+          <a:bodyPr wrap="square" rtlCol="0">
+            <a:spAutoFit/>
+          </a:bodyPr>
+          <a:lstStyle/>
+          <a:p>
+            <a:pPr algn="ctr"/>
+            <a:r>
+              <a:rPr lang="es-ES" sz="1400" dirty="0">
+                <a:solidFill>
+                  <a:srgbClr val="FF0000"/>
+                </a:solidFill>
+              </a:rPr>
+              <a:t>*</a:t>
+            </a:r>
+            <a:r>
+              <a:rPr lang="es-ES" sz="1400" dirty="0" err="1">
+                <a:solidFill>
+                  <a:srgbClr val="FF0000"/>
+                </a:solidFill>
+              </a:rPr>
+              <a:t>Images</a:t>
+            </a:r>
+            <a:r>
+              <a:rPr lang="es-ES" sz="1400" dirty="0">
+                <a:solidFill>
+                  <a:srgbClr val="FF0000"/>
+                </a:solidFill>
+              </a:rPr>
+              <a:t> </a:t>
+            </a:r>
+            <a:r>
+              <a:rPr lang="es-ES" sz="1400" dirty="0" err="1">
+                <a:solidFill>
+                  <a:srgbClr val="FF0000"/>
+                </a:solidFill>
+              </a:rPr>
+              <a:t>ordered</a:t>
+            </a:r>
+            <a:r>
+              <a:rPr lang="es-ES" sz="1400" dirty="0">
+                <a:solidFill>
+                  <a:srgbClr val="FF0000"/>
+                </a:solidFill>
+              </a:rPr>
+              <a:t> </a:t>
+            </a:r>
+            <a:r>
+              <a:rPr lang="es-ES" sz="1400" dirty="0" err="1">
+                <a:solidFill>
+                  <a:srgbClr val="FF0000"/>
+                </a:solidFill>
+              </a:rPr>
+              <a:t>according</a:t>
+            </a:r>
+            <a:r>
+              <a:rPr lang="es-ES" sz="1400" dirty="0">
+                <a:solidFill>
+                  <a:srgbClr val="FF0000"/>
+                </a:solidFill>
+              </a:rPr>
+              <a:t> </a:t>
+            </a:r>
+            <a:r>
+              <a:rPr lang="es-ES" sz="1400" dirty="0" err="1">
+                <a:solidFill>
+                  <a:srgbClr val="FF0000"/>
+                </a:solidFill>
+              </a:rPr>
+              <a:t>to</a:t>
+            </a:r>
+            <a:r>
+              <a:rPr lang="es-ES" sz="1400" dirty="0">
+                <a:solidFill>
+                  <a:srgbClr val="FF0000"/>
+                </a:solidFill>
+              </a:rPr>
+              <a:t> </a:t>
+            </a:r>
+            <a:r>
+              <a:rPr lang="es-ES" sz="1400" dirty="0" err="1">
+                <a:solidFill>
+                  <a:srgbClr val="FF0000"/>
+                </a:solidFill>
+              </a:rPr>
+              <a:t>their</a:t>
+            </a:r>
+            <a:r>
+              <a:rPr lang="es-ES" sz="1400" dirty="0">
+                <a:solidFill>
+                  <a:srgbClr val="FF0000"/>
+                </a:solidFill>
+              </a:rPr>
+              <a:t> (</a:t>
+            </a:r>
+            <a:r>
+              <a:rPr lang="es-ES" sz="1400" dirty="0" err="1">
+                <a:solidFill>
+                  <a:srgbClr val="FF0000"/>
+                </a:solidFill>
+              </a:rPr>
+              <a:t>increasing</a:t>
+            </a:r>
+            <a:r>
+              <a:rPr lang="es-ES" sz="1400" dirty="0">
+                <a:solidFill>
+                  <a:srgbClr val="FF0000"/>
+                </a:solidFill>
+              </a:rPr>
+              <a:t>) </a:t>
+            </a:r>
+            <a:r>
+              <a:rPr lang="es-ES" sz="1400" dirty="0" err="1">
+                <a:solidFill>
+                  <a:srgbClr val="FF0000"/>
+                </a:solidFill>
+              </a:rPr>
+              <a:t>probability</a:t>
+            </a:r>
+            <a:r>
+              <a:rPr lang="es-ES" sz="1400" dirty="0">
+                <a:solidFill>
+                  <a:srgbClr val="FF0000"/>
+                </a:solidFill>
+              </a:rPr>
+              <a:t> </a:t>
+            </a:r>
+            <a:r>
+              <a:rPr lang="es-ES" sz="1400" dirty="0" err="1">
+                <a:solidFill>
+                  <a:srgbClr val="FF0000"/>
+                </a:solidFill>
+              </a:rPr>
+              <a:t>of</a:t>
+            </a:r>
+            <a:r>
+              <a:rPr lang="es-ES" sz="1400" dirty="0">
+                <a:solidFill>
+                  <a:srgbClr val="FF0000"/>
+                </a:solidFill>
+              </a:rPr>
+              <a:t> “</a:t>
+            </a:r>
+            <a:r>
+              <a:rPr lang="es-ES" sz="1400" dirty="0" err="1">
+                <a:solidFill>
+                  <a:srgbClr val="FF0000"/>
+                </a:solidFill>
+              </a:rPr>
+              <a:t>being</a:t>
+            </a:r>
+            <a:r>
+              <a:rPr lang="es-ES" sz="1400" dirty="0">
+                <a:solidFill>
+                  <a:srgbClr val="FF0000"/>
+                </a:solidFill>
+              </a:rPr>
+              <a:t> a 5”</a:t>
+            </a:r>
+            <a:endParaRPr lang="en-US" sz="1400" dirty="0">
+              <a:solidFill>
+                <a:srgbClr val="FF0000"/>
+              </a:solidFill>
+            </a:endParaRPr>
+          </a:p>
+        </p:txBody>
+      </p:sp>
+      <p:sp>
+        <p:nvSpPr>
+          <p:cNvPr id="9" name="TextBox 8">
+            <a:extLst>
+              <a:ext uri="{FF2B5EF4-FFF2-40B4-BE49-F238E27FC236}">
+                <a16:creationId xmlns:a16="http://schemas.microsoft.com/office/drawing/2014/main" id="{E1954FAC-9C26-4E01-5260-4D6A0B3FD4A4}"/>
+              </a:ext>
+            </a:extLst>
+          </p:cNvPr>
+          <p:cNvSpPr txBox="1"/>
+          <p:nvPr/>
+        </p:nvSpPr>
+        <p:spPr>
+          <a:xfrm>
+            <a:off x="2866937" y="3873654"/>
+            <a:ext cx="1068217" cy="276999"/>
+          </a:xfrm>
+          <a:prstGeom prst="rect">
+            <a:avLst/>
+          </a:prstGeom>
+          <a:noFill/>
+        </p:spPr>
+        <p:txBody>
+          <a:bodyPr wrap="square" rtlCol="0">
+            <a:spAutoFit/>
+          </a:bodyPr>
+          <a:lstStyle/>
+          <a:p>
+            <a:pPr algn="ctr"/>
+            <a:r>
+              <a:rPr lang="es-ES" sz="1200" dirty="0">
+                <a:solidFill>
+                  <a:srgbClr val="FF0000"/>
+                </a:solidFill>
+              </a:rPr>
+              <a:t>TP</a:t>
+            </a:r>
+            <a:r>
+              <a:rPr lang="en-US" sz="1200" dirty="0">
+                <a:solidFill>
+                  <a:srgbClr val="FF0000"/>
+                </a:solidFill>
+              </a:rPr>
+              <a:t>/(TP+FP)</a:t>
+            </a:r>
+          </a:p>
+        </p:txBody>
+      </p:sp>
+      <p:sp>
+        <p:nvSpPr>
+          <p:cNvPr id="10" name="TextBox 9">
+            <a:extLst>
+              <a:ext uri="{FF2B5EF4-FFF2-40B4-BE49-F238E27FC236}">
+                <a16:creationId xmlns:a16="http://schemas.microsoft.com/office/drawing/2014/main" id="{A29FFB1B-A0A9-B55C-B155-77C01FCDD992}"/>
+              </a:ext>
+            </a:extLst>
+          </p:cNvPr>
+          <p:cNvSpPr txBox="1"/>
+          <p:nvPr/>
+        </p:nvSpPr>
+        <p:spPr>
+          <a:xfrm>
+            <a:off x="2882488" y="4050428"/>
+            <a:ext cx="1068217" cy="276999"/>
+          </a:xfrm>
+          <a:prstGeom prst="rect">
+            <a:avLst/>
+          </a:prstGeom>
+          <a:noFill/>
+        </p:spPr>
+        <p:txBody>
+          <a:bodyPr wrap="square" rtlCol="0">
+            <a:spAutoFit/>
+          </a:bodyPr>
+          <a:lstStyle/>
+          <a:p>
+            <a:pPr algn="ctr"/>
+            <a:r>
+              <a:rPr lang="es-ES" sz="1200" dirty="0">
+                <a:solidFill>
+                  <a:srgbClr val="FF0000"/>
+                </a:solidFill>
+              </a:rPr>
+              <a:t>TP</a:t>
+            </a:r>
+            <a:r>
+              <a:rPr lang="en-US" sz="1200" dirty="0">
+                <a:solidFill>
+                  <a:srgbClr val="FF0000"/>
+                </a:solidFill>
+              </a:rPr>
+              <a:t>/(TP+FN)</a:t>
+            </a:r>
+          </a:p>
+        </p:txBody>
+      </p:sp>
     </p:spTree>
     <p:extLst>
       <p:ext uri="{BB962C8B-B14F-4D97-AF65-F5344CB8AC3E}">
@@ -31294,7 +31041,7 @@
 </p:sld>
 </file>
 
-<file path=ppt/slides/slide22.xml><?xml version="1.0" encoding="utf-8"?>
+<file path=ppt/slides/slide21.xml><?xml version="1.0" encoding="utf-8"?>
 <p:sld xmlns:a="http://schemas.openxmlformats.org/drawingml/2006/main" xmlns:r="http://schemas.openxmlformats.org/officeDocument/2006/relationships" xmlns:p="http://schemas.openxmlformats.org/presentationml/2006/main">
   <p:cSld>
     <p:spTree>
@@ -31800,7 +31547,7 @@
 </p:sld>
 </file>
 
-<file path=ppt/slides/slide23.xml><?xml version="1.0" encoding="utf-8"?>
+<file path=ppt/slides/slide22.xml><?xml version="1.0" encoding="utf-8"?>
 <p:sld xmlns:a="http://schemas.openxmlformats.org/drawingml/2006/main" xmlns:r="http://schemas.openxmlformats.org/officeDocument/2006/relationships" xmlns:p="http://schemas.openxmlformats.org/presentationml/2006/main">
   <p:cSld>
     <p:spTree>
@@ -32252,7 +31999,7 @@
               <a:rPr lang="en-US" sz="2000" dirty="0">
                 <a:latin typeface="+mj-lt"/>
               </a:rPr>
-              <a:t>(FPR), or, which the same, </a:t>
+              <a:t>(FPR), or, which is the same, </a:t>
             </a:r>
             <a:r>
               <a:rPr lang="en-US" sz="2000" i="1" dirty="0">
@@ -32264,13 +32011,43 @@
               <a:rPr lang="en-US" sz="2000" dirty="0">
                 <a:latin typeface="+mj-lt"/>
               </a:rPr>
-              <a:t> (Recall) versus </a:t>
+              <a:t> (</a:t>
             </a:r>
             <a:r>
               <a:rPr lang="en-US" sz="2000" i="1" dirty="0">
                 <a:latin typeface="+mj-lt"/>
               </a:rPr>
-              <a:t>1 - Specificity</a:t>
+              <a:t>true positive rate</a:t>
+            </a:r>
+            <a:r>
+              <a:rPr lang="en-US" sz="2000" dirty="0">
+                <a:latin typeface="+mj-lt"/>
+              </a:rPr>
+              <a:t>) versus </a:t>
+            </a:r>
+            <a:r>
+              <a:rPr lang="en-US" sz="2000" i="1" dirty="0">
+                <a:latin typeface="+mj-lt"/>
+              </a:rPr>
+              <a:t>1 – Specificity </a:t>
+            </a:r>
+            <a:r>
+              <a:rPr lang="en-US" sz="2000" dirty="0">
+                <a:latin typeface="+mj-lt"/>
+              </a:rPr>
+              <a:t>(</a:t>
+            </a:r>
+            <a:r>
+              <a:rPr lang="en-US" sz="2000" i="1" dirty="0">
+                <a:latin typeface="+mj-lt"/>
+              </a:rPr>
+              <a:t>true negative rate</a:t>
+            </a:r>
+            <a:r>
+              <a:rPr lang="en-US" sz="2000" dirty="0">
+                <a:latin typeface="+mj-lt"/>
+              </a:rPr>
+              <a:t>)</a:t>
             </a:r>
           </a:p>
           <a:p>
@@ -32333,7 +32110,7 @@
         </p:blipFill>
         <p:spPr>
           <a:xfrm>
-            <a:off x="1471468" y="3156299"/>
+            <a:off x="1471468" y="3202345"/>
             <a:ext cx="3840488" cy="3155601"/>
           </a:xfrm>
           <a:prstGeom prst="rect">
@@ -32402,442 +32179,6 @@
     <p:extLst>
       <p:ext uri="{BB962C8B-B14F-4D97-AF65-F5344CB8AC3E}">
         <p14:creationId xmlns:p14="http://schemas.microsoft.com/office/powerpoint/2010/main" val="4119110571"/>
-      </p:ext>
-    </p:extLst>
-  </p:cSld>
-  <p:clrMapOvr>
-    <a:masterClrMapping/>
-  </p:clrMapOvr>
-</p:sld>
-</file>
-
-<file path=ppt/slides/slide24.xml><?xml version="1.0" encoding="utf-8"?>
-<p:sld xmlns:a="http://schemas.openxmlformats.org/drawingml/2006/main" xmlns:r="http://schemas.openxmlformats.org/officeDocument/2006/relationships" xmlns:p="http://schemas.openxmlformats.org/presentationml/2006/main">
-  <p:cSld>
-    <p:spTree>
-      <p:nvGrpSpPr>
-        <p:cNvPr id="1" name=""/>
-        <p:cNvGrpSpPr/>
-        <p:nvPr/>
-      </p:nvGrpSpPr>
-      <p:grpSpPr>
-        <a:xfrm>
-          <a:off x="0" y="0"/>
-          <a:ext cx="0" cy="0"/>
-          <a:chOff x="0" y="0"/>
-          <a:chExt cx="0" cy="0"/>
-        </a:xfrm>
-      </p:grpSpPr>
-      <p:sp>
-        <p:nvSpPr>
-          <p:cNvPr id="2" name="Title 1">
-            <a:extLst>
-              <a:ext uri="{FF2B5EF4-FFF2-40B4-BE49-F238E27FC236}">
-                <a16:creationId xmlns:a16="http://schemas.microsoft.com/office/drawing/2014/main" id="{15C869D5-4E6C-6766-7E06-98B25E955D87}"/>
-              </a:ext>
-            </a:extLst>
-          </p:cNvPr>
-          <p:cNvSpPr>
-            <a:spLocks noGrp="1"/>
-          </p:cNvSpPr>
-          <p:nvPr>
-            <p:ph type="title"/>
-          </p:nvPr>
-        </p:nvSpPr>
-        <p:spPr/>
-        <p:txBody>
-          <a:bodyPr>
-            <a:normAutofit/>
-          </a:bodyPr>
-          <a:lstStyle/>
-          <a:p>
-            <a:r>
-              <a:rPr lang="en-US" sz="4000" dirty="0"/>
-              <a:t>Performance measures</a:t>
-            </a:r>
-          </a:p>
-        </p:txBody>
-      </p:sp>
-      <p:sp>
-        <p:nvSpPr>
-          <p:cNvPr id="4" name="Rectángulo 3">
-            <a:extLst>
-              <a:ext uri="{FF2B5EF4-FFF2-40B4-BE49-F238E27FC236}">
-                <a16:creationId xmlns:a16="http://schemas.microsoft.com/office/drawing/2014/main" id="{27E372AA-1ACE-5D2D-EDED-66DB6F5F4F88}"/>
-              </a:ext>
-            </a:extLst>
-          </p:cNvPr>
-          <p:cNvSpPr/>
-          <p:nvPr/>
-        </p:nvSpPr>
-        <p:spPr>
-          <a:xfrm>
-            <a:off x="0" y="0"/>
-            <a:ext cx="374469" cy="6858000"/>
-          </a:xfrm>
-          <a:prstGeom prst="rect">
-            <a:avLst/>
-          </a:prstGeom>
-        </p:spPr>
-        <p:style>
-          <a:lnRef idx="2">
-            <a:schemeClr val="accent2">
-              <a:shade val="50000"/>
-            </a:schemeClr>
-          </a:lnRef>
-          <a:fillRef idx="1">
-            <a:schemeClr val="accent2"/>
-          </a:fillRef>
-          <a:effectRef idx="0">
-            <a:schemeClr val="accent2"/>
-          </a:effectRef>
-          <a:fontRef idx="minor">
-            <a:schemeClr val="lt1"/>
-          </a:fontRef>
-        </p:style>
-        <p:txBody>
-          <a:bodyPr rtlCol="0" anchor="ctr"/>
-          <a:lstStyle/>
-          <a:p>
-            <a:pPr algn="ctr"/>
-            <a:endParaRPr lang="es-ES"/>
-          </a:p>
-        </p:txBody>
-      </p:sp>
-      <p:sp>
-        <p:nvSpPr>
-          <p:cNvPr id="5" name="Rectangle 143">
-            <a:extLst>
-              <a:ext uri="{FF2B5EF4-FFF2-40B4-BE49-F238E27FC236}">
-                <a16:creationId xmlns:a16="http://schemas.microsoft.com/office/drawing/2014/main" id="{4CAC6C5C-8798-AF6F-C852-967659577BF3}"/>
-              </a:ext>
-            </a:extLst>
-          </p:cNvPr>
-          <p:cNvSpPr>
-            <a:spLocks noChangeArrowheads="1"/>
-          </p:cNvSpPr>
-          <p:nvPr/>
-        </p:nvSpPr>
-        <p:spPr bwMode="auto">
-          <a:xfrm>
-            <a:off x="448342" y="6482412"/>
-            <a:ext cx="5730175" cy="276999"/>
-          </a:xfrm>
-          <a:prstGeom prst="rect">
-            <a:avLst/>
-          </a:prstGeom>
-          <a:noFill/>
-          <a:ln>
-            <a:noFill/>
-          </a:ln>
-          <a:effectLst/>
-          <a:extLst>
-            <a:ext uri="{909E8E84-426E-40DD-AFC4-6F175D3DCCD1}">
-              <a14:hiddenFill xmlns:a14="http://schemas.microsoft.com/office/drawing/2010/main">
-                <a:solidFill>
-                  <a:schemeClr val="accent1"/>
-                </a:solidFill>
-              </a14:hiddenFill>
-            </a:ext>
-            <a:ext uri="{91240B29-F687-4F45-9708-019B960494DF}">
-              <a14:hiddenLine xmlns:a14="http://schemas.microsoft.com/office/drawing/2010/main" w="9525">
-                <a:solidFill>
-                  <a:schemeClr val="tx1"/>
-                </a:solidFill>
-                <a:miter lim="800000"/>
-                <a:headEnd/>
-                <a:tailEnd/>
-              </a14:hiddenLine>
-            </a:ext>
-            <a:ext uri="{AF507438-7753-43E0-B8FC-AC1667EBCBE1}">
-              <a14:hiddenEffects xmlns:a14="http://schemas.microsoft.com/office/drawing/2010/main">
-                <a:effectLst>
-                  <a:outerShdw dist="35921" dir="2700000" algn="ctr" rotWithShape="0">
-                    <a:schemeClr val="bg2"/>
-                  </a:outerShdw>
-                </a:effectLst>
-              </a14:hiddenEffects>
-            </a:ext>
-          </a:extLst>
-        </p:spPr>
-        <p:txBody>
-          <a:bodyPr vert="horz" wrap="square" lIns="91440" tIns="45720" rIns="91440" bIns="45720" numCol="1" anchor="ctr" anchorCtr="0" compatLnSpc="1">
-            <a:prstTxWarp prst="textNoShape">
-              <a:avLst/>
-            </a:prstTxWarp>
-            <a:spAutoFit/>
-          </a:bodyPr>
-          <a:lstStyle/>
-          <a:p>
-            <a:pPr marL="0" marR="0" lvl="0" indent="0" algn="l" defTabSz="914400" rtl="0" eaLnBrk="0" fontAlgn="base" latinLnBrk="0" hangingPunct="0">
-              <a:lnSpc>
-                <a:spcPct val="100000"/>
-              </a:lnSpc>
-              <a:spcBef>
-                <a:spcPct val="0"/>
-              </a:spcBef>
-              <a:spcAft>
-                <a:spcPct val="0"/>
-              </a:spcAft>
-              <a:buClrTx/>
-              <a:buSzTx/>
-              <a:buFontTx/>
-              <a:buNone/>
-              <a:tabLst/>
-            </a:pPr>
-            <a:r>
-              <a:rPr kumimoji="0" lang="en-US" altLang="es-ES" sz="1200" b="0" i="0" u="none" strike="noStrike" cap="none" normalizeH="0" baseline="0" dirty="0">
-                <a:ln>
-                  <a:noFill/>
-                </a:ln>
-                <a:solidFill>
-                  <a:srgbClr val="F4A200"/>
-                </a:solidFill>
-                <a:effectLst/>
-                <a:latin typeface="Arial" panose="020B0604020202020204" pitchFamily="34" charset="0"/>
-                <a:ea typeface="Myriad Pro Light"/>
-                <a:cs typeface="Times New Roman" panose="02020603050405020304" pitchFamily="18" charset="0"/>
-              </a:rPr>
-              <a:t>Master in Quantitative Economic Analysis </a:t>
-            </a:r>
-            <a:r>
-              <a:rPr kumimoji="0" lang="en-US" altLang="es-ES" sz="1200" b="0" i="0" u="none" strike="noStrike" cap="none" normalizeH="0" baseline="0" dirty="0" err="1">
-                <a:ln>
-                  <a:noFill/>
-                </a:ln>
-                <a:solidFill>
-                  <a:srgbClr val="F4A200"/>
-                </a:solidFill>
-                <a:effectLst/>
-                <a:latin typeface="Arial" panose="020B0604020202020204" pitchFamily="34" charset="0"/>
-                <a:ea typeface="Myriad Pro Light"/>
-                <a:cs typeface="Times New Roman" panose="02020603050405020304" pitchFamily="18" charset="0"/>
-              </a:rPr>
-              <a:t>MQuEA</a:t>
-            </a:r>
-            <a:endParaRPr kumimoji="0" lang="es-ES" altLang="es-ES" sz="400" b="0" i="0" u="none" strike="noStrike" cap="none" normalizeH="0" baseline="0" dirty="0">
-              <a:ln>
-                <a:noFill/>
-              </a:ln>
-              <a:solidFill>
-                <a:schemeClr val="tx1"/>
-              </a:solidFill>
-              <a:effectLst/>
-              <a:latin typeface="Arial" panose="020B0604020202020204" pitchFamily="34" charset="0"/>
-            </a:endParaRPr>
-          </a:p>
-        </p:txBody>
-      </p:sp>
-      <p:sp>
-        <p:nvSpPr>
-          <p:cNvPr id="6" name="Rectangle 143">
-            <a:extLst>
-              <a:ext uri="{FF2B5EF4-FFF2-40B4-BE49-F238E27FC236}">
-                <a16:creationId xmlns:a16="http://schemas.microsoft.com/office/drawing/2014/main" id="{09E0FB32-C00A-A390-E094-76FC3EA5C288}"/>
-              </a:ext>
-            </a:extLst>
-          </p:cNvPr>
-          <p:cNvSpPr>
-            <a:spLocks noChangeArrowheads="1"/>
-          </p:cNvSpPr>
-          <p:nvPr/>
-        </p:nvSpPr>
-        <p:spPr bwMode="auto">
-          <a:xfrm>
-            <a:off x="6186394" y="6493050"/>
-            <a:ext cx="5730175" cy="276999"/>
-          </a:xfrm>
-          <a:prstGeom prst="rect">
-            <a:avLst/>
-          </a:prstGeom>
-          <a:noFill/>
-          <a:ln>
-            <a:noFill/>
-          </a:ln>
-          <a:effectLst/>
-          <a:extLst>
-            <a:ext uri="{909E8E84-426E-40DD-AFC4-6F175D3DCCD1}">
-              <a14:hiddenFill xmlns:a14="http://schemas.microsoft.com/office/drawing/2010/main">
-                <a:solidFill>
-                  <a:schemeClr val="accent1"/>
-                </a:solidFill>
-              </a14:hiddenFill>
-            </a:ext>
-            <a:ext uri="{91240B29-F687-4F45-9708-019B960494DF}">
-              <a14:hiddenLine xmlns:a14="http://schemas.microsoft.com/office/drawing/2010/main" w="9525">
-                <a:solidFill>
-                  <a:schemeClr val="tx1"/>
-                </a:solidFill>
-                <a:miter lim="800000"/>
-                <a:headEnd/>
-                <a:tailEnd/>
-              </a14:hiddenLine>
-            </a:ext>
-            <a:ext uri="{AF507438-7753-43E0-B8FC-AC1667EBCBE1}">
-              <a14:hiddenEffects xmlns:a14="http://schemas.microsoft.com/office/drawing/2010/main">
-                <a:effectLst>
-                  <a:outerShdw dist="35921" dir="2700000" algn="ctr" rotWithShape="0">
-                    <a:schemeClr val="bg2"/>
-                  </a:outerShdw>
-                </a:effectLst>
-              </a14:hiddenEffects>
-            </a:ext>
-          </a:extLst>
-        </p:spPr>
-        <p:txBody>
-          <a:bodyPr vert="horz" wrap="square" lIns="91440" tIns="45720" rIns="91440" bIns="45720" numCol="1" anchor="ctr" anchorCtr="0" compatLnSpc="1">
-            <a:prstTxWarp prst="textNoShape">
-              <a:avLst/>
-            </a:prstTxWarp>
-            <a:spAutoFit/>
-          </a:bodyPr>
-          <a:lstStyle/>
-          <a:p>
-            <a:pPr marL="0" marR="0" lvl="0" indent="0" algn="r" defTabSz="914400" rtl="0" eaLnBrk="0" fontAlgn="base" latinLnBrk="0" hangingPunct="0">
-              <a:lnSpc>
-                <a:spcPct val="100000"/>
-              </a:lnSpc>
-              <a:spcBef>
-                <a:spcPct val="0"/>
-              </a:spcBef>
-              <a:spcAft>
-                <a:spcPct val="0"/>
-              </a:spcAft>
-              <a:buClrTx/>
-              <a:buSzTx/>
-              <a:buFontTx/>
-              <a:buNone/>
-              <a:tabLst/>
-            </a:pPr>
-            <a:r>
-              <a:rPr kumimoji="0" lang="en-US" altLang="es-ES" sz="1200" b="0" i="0" u="none" strike="noStrike" cap="none" normalizeH="0" baseline="0" dirty="0">
-                <a:ln>
-                  <a:noFill/>
-                </a:ln>
-                <a:solidFill>
-                  <a:srgbClr val="F4A200"/>
-                </a:solidFill>
-                <a:effectLst/>
-                <a:latin typeface="Arial" panose="020B0604020202020204" pitchFamily="34" charset="0"/>
-                <a:ea typeface="Myriad Pro Light"/>
-                <a:cs typeface="Times New Roman" panose="02020603050405020304" pitchFamily="18" charset="0"/>
-              </a:rPr>
-              <a:t>Universidad </a:t>
-            </a:r>
-            <a:r>
-              <a:rPr kumimoji="0" lang="en-US" altLang="es-ES" sz="1200" b="0" i="0" u="none" strike="noStrike" cap="none" normalizeH="0" baseline="0" dirty="0" err="1">
-                <a:ln>
-                  <a:noFill/>
-                </a:ln>
-                <a:solidFill>
-                  <a:srgbClr val="F4A200"/>
-                </a:solidFill>
-                <a:effectLst/>
-                <a:latin typeface="Arial" panose="020B0604020202020204" pitchFamily="34" charset="0"/>
-                <a:ea typeface="Myriad Pro Light"/>
-                <a:cs typeface="Times New Roman" panose="02020603050405020304" pitchFamily="18" charset="0"/>
-              </a:rPr>
-              <a:t>Aut</a:t>
-            </a:r>
-            <a:r>
-              <a:rPr lang="en-US" altLang="es-ES" sz="1200" dirty="0" err="1">
-                <a:solidFill>
-                  <a:srgbClr val="F4A200"/>
-                </a:solidFill>
-                <a:latin typeface="Arial" panose="020B0604020202020204" pitchFamily="34" charset="0"/>
-                <a:ea typeface="Myriad Pro Light"/>
-                <a:cs typeface="Times New Roman" panose="02020603050405020304" pitchFamily="18" charset="0"/>
-              </a:rPr>
-              <a:t>ó</a:t>
-            </a:r>
-            <a:r>
-              <a:rPr kumimoji="0" lang="en-US" altLang="es-ES" sz="1200" b="0" i="0" u="none" strike="noStrike" cap="none" normalizeH="0" baseline="0" dirty="0" err="1">
-                <a:ln>
-                  <a:noFill/>
-                </a:ln>
-                <a:solidFill>
-                  <a:srgbClr val="F4A200"/>
-                </a:solidFill>
-                <a:effectLst/>
-                <a:latin typeface="Arial" panose="020B0604020202020204" pitchFamily="34" charset="0"/>
-                <a:ea typeface="Myriad Pro Light"/>
-                <a:cs typeface="Times New Roman" panose="02020603050405020304" pitchFamily="18" charset="0"/>
-              </a:rPr>
-              <a:t>noma</a:t>
-            </a:r>
-            <a:r>
-              <a:rPr kumimoji="0" lang="en-US" altLang="es-ES" sz="1200" b="0" i="0" u="none" strike="noStrike" cap="none" normalizeH="0" baseline="0" dirty="0">
-                <a:ln>
-                  <a:noFill/>
-                </a:ln>
-                <a:solidFill>
-                  <a:srgbClr val="F4A200"/>
-                </a:solidFill>
-                <a:effectLst/>
-                <a:latin typeface="Arial" panose="020B0604020202020204" pitchFamily="34" charset="0"/>
-                <a:ea typeface="Myriad Pro Light"/>
-                <a:cs typeface="Times New Roman" panose="02020603050405020304" pitchFamily="18" charset="0"/>
-              </a:rPr>
-              <a:t> de Madrid</a:t>
-            </a:r>
-            <a:endParaRPr kumimoji="0" lang="es-ES" altLang="es-ES" sz="400" b="0" i="0" u="none" strike="noStrike" cap="none" normalizeH="0" baseline="0" dirty="0">
-              <a:ln>
-                <a:noFill/>
-              </a:ln>
-              <a:solidFill>
-                <a:schemeClr val="tx1"/>
-              </a:solidFill>
-              <a:effectLst/>
-              <a:latin typeface="Arial" panose="020B0604020202020204" pitchFamily="34" charset="0"/>
-            </a:endParaRPr>
-          </a:p>
-        </p:txBody>
-      </p:sp>
-      <p:sp>
-        <p:nvSpPr>
-          <p:cNvPr id="3" name="Content Placeholder 2">
-            <a:extLst>
-              <a:ext uri="{FF2B5EF4-FFF2-40B4-BE49-F238E27FC236}">
-                <a16:creationId xmlns:a16="http://schemas.microsoft.com/office/drawing/2014/main" id="{F7EF27C5-01B7-9F60-ECDA-A1F376586FC5}"/>
-              </a:ext>
-            </a:extLst>
-          </p:cNvPr>
-          <p:cNvSpPr>
-            <a:spLocks noGrp="1"/>
-          </p:cNvSpPr>
-          <p:nvPr>
-            <p:ph idx="1"/>
-          </p:nvPr>
-        </p:nvSpPr>
-        <p:spPr/>
-        <p:txBody>
-          <a:bodyPr anchor="ctr">
-            <a:normAutofit/>
-          </a:bodyPr>
-          <a:lstStyle/>
-          <a:p>
-            <a:pPr marL="0" indent="0" algn="ctr">
-              <a:lnSpc>
-                <a:spcPct val="100000"/>
-              </a:lnSpc>
-              <a:buNone/>
-            </a:pPr>
-            <a:r>
-              <a:rPr lang="en-US" sz="3200" dirty="0">
-                <a:latin typeface="+mj-lt"/>
-              </a:rPr>
-              <a:t>Let’s jump into the notebook to see all of this in practice and estimating a couple of classifiers</a:t>
-            </a:r>
-            <a:endParaRPr lang="en-US" sz="3200" b="1" i="1" dirty="0">
-              <a:latin typeface="+mj-lt"/>
-            </a:endParaRPr>
-          </a:p>
-        </p:txBody>
-      </p:sp>
-    </p:spTree>
-    <p:extLst>
-      <p:ext uri="{BB962C8B-B14F-4D97-AF65-F5344CB8AC3E}">
-        <p14:creationId xmlns:p14="http://schemas.microsoft.com/office/powerpoint/2010/main" val="2805654642"/>
       </p:ext>
     </p:extLst>
   </p:cSld>
@@ -36082,8 +35423,8 @@
           </a:graphicData>
         </a:graphic>
       </p:graphicFrame>
-      <mc:AlternateContent xmlns:mc="http://schemas.openxmlformats.org/markup-compatibility/2006">
-        <mc:Choice xmlns:a14="http://schemas.microsoft.com/office/drawing/2010/main" Requires="a14">
+      <mc:AlternateContent xmlns:mc="http://schemas.openxmlformats.org/markup-compatibility/2006" xmlns:a14="http://schemas.microsoft.com/office/drawing/2010/main">
+        <mc:Choice Requires="a14">
           <p:sp>
             <p:nvSpPr>
               <p:cNvPr id="8" name="TextBox 7">
@@ -36273,7 +35614,7 @@
             </p:txBody>
           </p:sp>
         </mc:Choice>
-        <mc:Fallback>
+        <mc:Fallback xmlns="">
           <p:sp>
             <p:nvSpPr>
               <p:cNvPr id="8" name="TextBox 7">
@@ -36378,8 +35719,8 @@
           </a:p>
         </p:txBody>
       </p:sp>
-      <mc:AlternateContent xmlns:mc="http://schemas.openxmlformats.org/markup-compatibility/2006">
-        <mc:Choice xmlns:a14="http://schemas.microsoft.com/office/drawing/2010/main" Requires="a14">
+      <mc:AlternateContent xmlns:mc="http://schemas.openxmlformats.org/markup-compatibility/2006" xmlns:a14="http://schemas.microsoft.com/office/drawing/2010/main">
+        <mc:Choice Requires="a14">
           <p:sp>
             <p:nvSpPr>
               <p:cNvPr id="3" name="Content Placeholder 2">
@@ -36600,7 +35941,7 @@
             </p:txBody>
           </p:sp>
         </mc:Choice>
-        <mc:Fallback>
+        <mc:Fallback xmlns="">
           <p:sp>
             <p:nvSpPr>
               <p:cNvPr id="3" name="Content Placeholder 2">

</xml_diff>